<commit_message>
style(docs): update slides to use simple, natural, conversational SDE presentation English
</commit_message>
<xml_diff>
--- a/healthconnect-presentation.pptx
+++ b/healthconnect-presentation.pptx
@@ -1875,7 +1875,7 @@
         </p:nvSpPr>
         <p:spPr>
           <a:xfrm>
-            <a:off x="731520" y="1371600"/>
+            <a:off x="731520" y="1097280"/>
             <a:ext cx="7772400" cy="731520"/>
           </a:xfrm>
           <a:prstGeom prst="rect">
@@ -1892,7 +1892,7 @@
               <a:buNone/>
             </a:pPr>
             <a:r>
-              <a:rPr lang="en-US" sz="4800" b="1" dirty="0">
+              <a:rPr lang="en-US" sz="4400" b="1" dirty="0">
                 <a:solidFill>
                   <a:srgbClr val="2563EB"/>
                 </a:solidFill>
@@ -1902,7 +1902,7 @@
               </a:rPr>
               <a:t>HealthConnect</a:t>
             </a:r>
-            <a:endParaRPr lang="en-US" sz="4800" dirty="0"/>
+            <a:endParaRPr lang="en-US" sz="4400" dirty="0"/>
           </a:p>
         </p:txBody>
       </p:sp>
@@ -1914,7 +1914,7 @@
         </p:nvSpPr>
         <p:spPr>
           <a:xfrm>
-            <a:off x="731520" y="2103120"/>
+            <a:off x="731520" y="1737360"/>
             <a:ext cx="7772400" cy="457200"/>
           </a:xfrm>
           <a:prstGeom prst="rect">
@@ -1931,7 +1931,7 @@
               <a:buNone/>
             </a:pPr>
             <a:r>
-              <a:rPr lang="en-US" sz="2200" b="1" dirty="0">
+              <a:rPr lang="en-US" sz="2000" b="1" dirty="0">
                 <a:solidFill>
                   <a:srgbClr val="1E293B"/>
                 </a:solidFill>
@@ -1939,9 +1939,9 @@
                 <a:ea typeface="Segoe UI" pitchFamily="34" charset="-122"/>
                 <a:cs typeface="Segoe UI" pitchFamily="34" charset="-120"/>
               </a:rPr>
-              <a:t>Distributed Clinical Gateway &amp; Smart Triage Engine</a:t>
-            </a:r>
-            <a:endParaRPr lang="en-US" sz="2200" dirty="0"/>
+              <a:t>A simple booking and medical report parsing platform</a:t>
+            </a:r>
+            <a:endParaRPr lang="en-US" sz="2000" dirty="0"/>
           </a:p>
         </p:txBody>
       </p:sp>
@@ -1953,8 +1953,8 @@
         </p:nvSpPr>
         <p:spPr>
           <a:xfrm>
-            <a:off x="731520" y="2651760"/>
-            <a:ext cx="7772400" cy="365760"/>
+            <a:off x="731520" y="2468880"/>
+            <a:ext cx="7772400" cy="1371600"/>
           </a:xfrm>
           <a:prstGeom prst="rect">
             <a:avLst/>
@@ -1970,41 +1970,16 @@
               <a:buNone/>
             </a:pPr>
             <a:r>
-              <a:rPr lang="en-US" sz="1400" i="1" dirty="0">
-                <a:solidFill>
-                  <a:srgbClr val="64748B"/>
-                </a:solidFill>
-                <a:latin typeface="Segoe UI" pitchFamily="34" charset="0"/>
-                <a:ea typeface="Segoe UI" pitchFamily="34" charset="-122"/>
-                <a:cs typeface="Segoe UI" pitchFamily="34" charset="-120"/>
-              </a:rPr>
-              <a:t>AI-Powered Patient Routing &amp; Concurrency-Safe Clinic Resource Scheduling</a:t>
-            </a:r>
-            <a:endParaRPr lang="en-US" sz="1400" dirty="0"/>
-          </a:p>
-        </p:txBody>
-      </p:sp>
-      <p:sp>
-        <p:nvSpPr>
-          <p:cNvPr id="6" name="Text 4"/>
-          <p:cNvSpPr/>
-          <p:nvPr/>
-        </p:nvSpPr>
-        <p:spPr>
-          <a:xfrm>
-            <a:off x="731520" y="3291840"/>
-            <a:ext cx="7772400" cy="1371600"/>
-          </a:xfrm>
-          <a:prstGeom prst="rect">
-            <a:avLst/>
-          </a:prstGeom>
-          <a:noFill/>
-          <a:ln/>
-        </p:spPr>
-        <p:txBody>
-          <a:bodyPr wrap="square" rtlCol="0" anchor="ctr"/>
-          <a:lstStyle/>
-          <a:p>
+              <a:rPr lang="en-US" sz="1300" b="1" dirty="0">
+                <a:solidFill>
+                  <a:srgbClr val="2563EB"/>
+                </a:solidFill>
+                <a:latin typeface="Segoe UI" pitchFamily="34" charset="0"/>
+                <a:ea typeface="Segoe UI" pitchFamily="34" charset="-122"/>
+                <a:cs typeface="Segoe UI" pitchFamily="34" charset="-120"/>
+              </a:rPr>
+              <a:t>• Domain: </a:t>
+            </a:r>
             <a:pPr indent="0" marL="0">
               <a:buNone/>
             </a:pPr>
@@ -2017,13 +1992,27 @@
                 <a:ea typeface="Segoe UI" pitchFamily="34" charset="-122"/>
                 <a:cs typeface="Segoe UI" pitchFamily="34" charset="-120"/>
               </a:rPr>
-              <a:t>• Hybrid database abstraction pattern supporting transactional serverless Postgres.
+              <a:t>Healthcare &amp; Digital Medical Records
 </a:t>
             </a:r>
             <a:pPr indent="0" marL="0">
               <a:buNone/>
             </a:pPr>
             <a:r>
+              <a:rPr lang="en-US" sz="1300" b="1" dirty="0">
+                <a:solidFill>
+                  <a:srgbClr val="2563EB"/>
+                </a:solidFill>
+                <a:latin typeface="Segoe UI" pitchFamily="34" charset="0"/>
+                <a:ea typeface="Segoe UI" pitchFamily="34" charset="-122"/>
+                <a:cs typeface="Segoe UI" pitchFamily="34" charset="-120"/>
+              </a:rPr>
+              <a:t>• Core Stack: </a:t>
+            </a:r>
+            <a:pPr indent="0" marL="0">
+              <a:buNone/>
+            </a:pPr>
+            <a:r>
               <a:rPr lang="en-US" sz="1300" dirty="0">
                 <a:solidFill>
                   <a:srgbClr val="1E293B"/>
@@ -2032,13 +2021,27 @@
                 <a:ea typeface="Segoe UI" pitchFamily="34" charset="-122"/>
                 <a:cs typeface="Segoe UI" pitchFamily="34" charset="-120"/>
               </a:rPr>
-              <a:t>• High-concurrency schedule isolation via pessimistic database lease locking.
+              <a:t>React, Node.js, Express, PostgreSQL, Python Flask, Cloudinary CDN
 </a:t>
             </a:r>
             <a:pPr indent="0" marL="0">
               <a:buNone/>
             </a:pPr>
             <a:r>
+              <a:rPr lang="en-US" sz="1300" b="1" dirty="0">
+                <a:solidFill>
+                  <a:srgbClr val="2563EB"/>
+                </a:solidFill>
+                <a:latin typeface="Segoe UI" pitchFamily="34" charset="0"/>
+                <a:ea typeface="Segoe UI" pitchFamily="34" charset="-122"/>
+                <a:cs typeface="Segoe UI" pitchFamily="34" charset="-120"/>
+              </a:rPr>
+              <a:t>• Main Impact: </a:t>
+            </a:r>
+            <a:pPr indent="0" marL="0">
+              <a:buNone/>
+            </a:pPr>
+            <a:r>
               <a:rPr lang="en-US" sz="1300" dirty="0">
                 <a:solidFill>
                   <a:srgbClr val="1E293B"/>
@@ -2047,7 +2050,7 @@
                 <a:ea typeface="Segoe UI" pitchFamily="34" charset="-122"/>
                 <a:cs typeface="Segoe UI" pitchFamily="34" charset="-120"/>
               </a:rPr>
-              <a:t>• CPU-bound document OCR processing isolated into an independent service node.</a:t>
+              <a:t>Speeds up booking and automatically triages patients based on report scans.</a:t>
             </a:r>
             <a:endParaRPr lang="en-US" sz="1300" dirty="0"/>
           </a:p>
@@ -2103,7 +2106,7 @@
               <a:buNone/>
             </a:pPr>
             <a:r>
-              <a:rPr lang="en-US" sz="2800" b="1" dirty="0">
+              <a:rPr lang="en-US" sz="2600" b="1" dirty="0">
                 <a:solidFill>
                   <a:srgbClr val="2563EB"/>
                 </a:solidFill>
@@ -2111,9 +2114,9 @@
                 <a:ea typeface="Segoe UI" pitchFamily="34" charset="-122"/>
                 <a:cs typeface="Segoe UI" pitchFamily="34" charset="-120"/>
               </a:rPr>
-              <a:t>Engineering Challenges &amp; Solutions</a:t>
-            </a:r>
-            <a:endParaRPr lang="en-US" sz="2800" dirty="0"/>
+              <a:t>Engineering Challenges Faced</a:t>
+            </a:r>
+            <a:endParaRPr lang="en-US" sz="2600" dirty="0"/>
           </a:p>
         </p:txBody>
       </p:sp>
@@ -2132,8 +2135,8 @@
           </p:nvPr>
         </p:nvGraphicFramePr>
         <p:xfrm>
-          <a:off x="731520" y="1188720"/>
-          <a:ext cx="7680960" cy="3200400"/>
+          <a:off x="731520" y="1097280"/>
+          <a:ext cx="7680960" cy="3291840"/>
         </p:xfrm>
         <a:graphic>
           <a:graphicData uri="http://schemas.openxmlformats.org/drawingml/2006/table">
@@ -2144,7 +2147,7 @@
                 <a:gridCol w="2560320"/>
                 <a:gridCol w="2560320"/>
               </a:tblGrid>
-              <a:tr h="800100">
+              <a:tr h="822960">
                 <a:tc>
                   <a:txBody>
                     <a:bodyPr/>
@@ -2154,7 +2157,7 @@
                         <a:buNone/>
                       </a:pPr>
                       <a:r>
-                        <a:rPr lang="en-US" sz="1000" b="1" dirty="0">
+                        <a:rPr lang="en-US" sz="950" b="1" dirty="0">
                           <a:solidFill>
                             <a:srgbClr val="FFFFFF"/>
                           </a:solidFill>
@@ -2162,9 +2165,9 @@
                           <a:ea typeface="Segoe UI" pitchFamily="34" charset="-122"/>
                           <a:cs typeface="Segoe UI" pitchFamily="34" charset="-120"/>
                         </a:rPr>
-                        <a:t>Engineering Challenge Faced</a:t>
+                        <a:t>Engineering Challenge</a:t>
                       </a:r>
-                      <a:endParaRPr lang="en-US" sz="1000" dirty="0">
+                      <a:endParaRPr lang="en-US" sz="950" dirty="0">
                         <a:latin typeface="Segoe UI" charset="0"/>
                         <a:ea typeface="Segoe UI" charset="0"/>
                         <a:cs typeface="Segoe UI" charset="0"/>
@@ -2222,7 +2225,7 @@
                         <a:buNone/>
                       </a:pPr>
                       <a:r>
-                        <a:rPr lang="en-US" sz="1000" b="1" dirty="0">
+                        <a:rPr lang="en-US" sz="950" b="1" dirty="0">
                           <a:solidFill>
                             <a:srgbClr val="FFFFFF"/>
                           </a:solidFill>
@@ -2230,9 +2233,9 @@
                           <a:ea typeface="Segoe UI" pitchFamily="34" charset="-122"/>
                           <a:cs typeface="Segoe UI" pitchFamily="34" charset="-120"/>
                         </a:rPr>
-                        <a:t>Underlying Technical Cause</a:t>
+                        <a:t>Why It Happened</a:t>
                       </a:r>
-                      <a:endParaRPr lang="en-US" sz="1000" dirty="0">
+                      <a:endParaRPr lang="en-US" sz="950" dirty="0">
                         <a:latin typeface="Segoe UI" charset="0"/>
                         <a:ea typeface="Segoe UI" charset="0"/>
                         <a:cs typeface="Segoe UI" charset="0"/>
@@ -2290,7 +2293,7 @@
                         <a:buNone/>
                       </a:pPr>
                       <a:r>
-                        <a:rPr lang="en-US" sz="1000" b="1" dirty="0">
+                        <a:rPr lang="en-US" sz="950" b="1" dirty="0">
                           <a:solidFill>
                             <a:srgbClr val="FFFFFF"/>
                           </a:solidFill>
@@ -2298,9 +2301,9 @@
                           <a:ea typeface="Segoe UI" pitchFamily="34" charset="-122"/>
                           <a:cs typeface="Segoe UI" pitchFamily="34" charset="-120"/>
                         </a:rPr>
-                        <a:t>Implemented Architectural Resolution</a:t>
+                        <a:t>How I Solved It</a:t>
                       </a:r>
-                      <a:endParaRPr lang="en-US" sz="1000" dirty="0">
+                      <a:endParaRPr lang="en-US" sz="950" dirty="0">
                         <a:latin typeface="Segoe UI" charset="0"/>
                         <a:ea typeface="Segoe UI" charset="0"/>
                         <a:cs typeface="Segoe UI" charset="0"/>
@@ -2350,7 +2353,7 @@
                   </a:tcPr>
                 </a:tc>
               </a:tr>
-              <a:tr h="800100">
+              <a:tr h="822960">
                 <a:tc>
                   <a:txBody>
                     <a:bodyPr/>
@@ -2360,7 +2363,7 @@
                         <a:buNone/>
                       </a:pPr>
                       <a:r>
-                        <a:rPr lang="en-US" sz="1000" dirty="0">
+                        <a:rPr lang="en-US" sz="950" dirty="0">
                           <a:solidFill>
                             <a:srgbClr val="000000"/>
                           </a:solidFill>
@@ -2368,9 +2371,9 @@
                           <a:ea typeface="Segoe UI" pitchFamily="34" charset="-122"/>
                           <a:cs typeface="Segoe UI" pitchFamily="34" charset="-120"/>
                         </a:rPr>
-                        <a:t>PostgreSQL Lowercase Key Folding</a:t>
+                        <a:t>PostgreSQL Lowercase Key Bug</a:t>
                       </a:r>
-                      <a:endParaRPr lang="en-US" sz="1000" dirty="0">
+                      <a:endParaRPr lang="en-US" sz="950" dirty="0">
                         <a:latin typeface="Segoe UI" charset="0"/>
                         <a:ea typeface="Segoe UI" charset="0"/>
                         <a:cs typeface="Segoe UI" charset="0"/>
@@ -2425,7 +2428,7 @@
                         <a:buNone/>
                       </a:pPr>
                       <a:r>
-                        <a:rPr lang="en-US" sz="1000" dirty="0">
+                        <a:rPr lang="en-US" sz="950" dirty="0">
                           <a:solidFill>
                             <a:srgbClr val="000000"/>
                           </a:solidFill>
@@ -2433,9 +2436,9 @@
                           <a:ea typeface="Segoe UI" pitchFamily="34" charset="-122"/>
                           <a:cs typeface="Segoe UI" pitchFamily="34" charset="-120"/>
                         </a:rPr>
-                        <a:t>PostgreSQL automatically downcases columns returned in queries, breaking camelCase properties in React.</a:t>
+                        <a:t>PostgreSQL changes column names returned in queries to all-lowercase, breaking camelCase keys in React.</a:t>
                       </a:r>
-                      <a:endParaRPr lang="en-US" sz="1000" dirty="0">
+                      <a:endParaRPr lang="en-US" sz="950" dirty="0">
                         <a:latin typeface="Segoe UI" charset="0"/>
                         <a:ea typeface="Segoe UI" charset="0"/>
                         <a:cs typeface="Segoe UI" charset="0"/>
@@ -2490,7 +2493,7 @@
                         <a:buNone/>
                       </a:pPr>
                       <a:r>
-                        <a:rPr lang="en-US" sz="1000" dirty="0">
+                        <a:rPr lang="en-US" sz="950" dirty="0">
                           <a:solidFill>
                             <a:srgbClr val="000000"/>
                           </a:solidFill>
@@ -2498,9 +2501,9 @@
                           <a:ea typeface="Segoe UI" pitchFamily="34" charset="-122"/>
                           <a:cs typeface="Segoe UI" pitchFamily="34" charset="-120"/>
                         </a:rPr>
-                        <a:t>Built a central mapping interceptor in the dbHelpers.js layer to dynamically normalize returned row keys to camelCase.</a:t>
+                        <a:t>Built a central mapping interceptor in dbHelpers.js to normalize returning rows back to camelCase before sending them.</a:t>
                       </a:r>
-                      <a:endParaRPr lang="en-US" sz="1000" dirty="0">
+                      <a:endParaRPr lang="en-US" sz="950" dirty="0">
                         <a:latin typeface="Segoe UI" charset="0"/>
                         <a:ea typeface="Segoe UI" charset="0"/>
                         <a:cs typeface="Segoe UI" charset="0"/>
@@ -2547,7 +2550,7 @@
                   </a:tcPr>
                 </a:tc>
               </a:tr>
-              <a:tr h="800100">
+              <a:tr h="822960">
                 <a:tc>
                   <a:txBody>
                     <a:bodyPr/>
@@ -2557,7 +2560,7 @@
                         <a:buNone/>
                       </a:pPr>
                       <a:r>
-                        <a:rPr lang="en-US" sz="1000" dirty="0">
+                        <a:rPr lang="en-US" sz="950" dirty="0">
                           <a:solidFill>
                             <a:srgbClr val="000000"/>
                           </a:solidFill>
@@ -2565,9 +2568,9 @@
                           <a:ea typeface="Segoe UI" pitchFamily="34" charset="-122"/>
                           <a:cs typeface="Segoe UI" pitchFamily="34" charset="-120"/>
                         </a:rPr>
-                        <a:t>Event-Loop Blocking OCR Tasks</a:t>
+                        <a:t>Monolithic Latency / Slow Node</a:t>
                       </a:r>
-                      <a:endParaRPr lang="en-US" sz="1000" dirty="0">
+                      <a:endParaRPr lang="en-US" sz="950" dirty="0">
                         <a:latin typeface="Segoe UI" charset="0"/>
                         <a:ea typeface="Segoe UI" charset="0"/>
                         <a:cs typeface="Segoe UI" charset="0"/>
@@ -2622,7 +2625,7 @@
                         <a:buNone/>
                       </a:pPr>
                       <a:r>
-                        <a:rPr lang="en-US" sz="1000" dirty="0">
+                        <a:rPr lang="en-US" sz="950" dirty="0">
                           <a:solidFill>
                             <a:srgbClr val="000000"/>
                           </a:solidFill>
@@ -2630,9 +2633,9 @@
                           <a:ea typeface="Segoe UI" pitchFamily="34" charset="-122"/>
                           <a:cs typeface="Segoe UI" pitchFamily="34" charset="-120"/>
                         </a:rPr>
-                        <a:t>Synchronous OCR processing inline in Node blocked the single event loop thread, spiking server latency.</a:t>
+                        <a:t>Text scanning (OCR) takes high CPU processing. Inline execution frozen main server API threads.</a:t>
                       </a:r>
-                      <a:endParaRPr lang="en-US" sz="1000" dirty="0">
+                      <a:endParaRPr lang="en-US" sz="950" dirty="0">
                         <a:latin typeface="Segoe UI" charset="0"/>
                         <a:ea typeface="Segoe UI" charset="0"/>
                         <a:cs typeface="Segoe UI" charset="0"/>
@@ -2687,7 +2690,7 @@
                         <a:buNone/>
                       </a:pPr>
                       <a:r>
-                        <a:rPr lang="en-US" sz="1000" dirty="0">
+                        <a:rPr lang="en-US" sz="950" dirty="0">
                           <a:solidFill>
                             <a:srgbClr val="000000"/>
                           </a:solidFill>
@@ -2695,9 +2698,9 @@
                           <a:ea typeface="Segoe UI" pitchFamily="34" charset="-122"/>
                           <a:cs typeface="Segoe UI" pitchFamily="34" charset="-120"/>
                         </a:rPr>
-                        <a:t>Decoupled the CPU-bound OCR logic into a dedicated Python Flask microservice node, preserving Gateway throughput.</a:t>
+                        <a:t>Decoupled the text extractor into a separate Python Flask microservice, keeping Node.js completely responsive.</a:t>
                       </a:r>
-                      <a:endParaRPr lang="en-US" sz="1000" dirty="0">
+                      <a:endParaRPr lang="en-US" sz="950" dirty="0">
                         <a:latin typeface="Segoe UI" charset="0"/>
                         <a:ea typeface="Segoe UI" charset="0"/>
                         <a:cs typeface="Segoe UI" charset="0"/>
@@ -2744,7 +2747,7 @@
                   </a:tcPr>
                 </a:tc>
               </a:tr>
-              <a:tr h="800100">
+              <a:tr h="822960">
                 <a:tc>
                   <a:txBody>
                     <a:bodyPr/>
@@ -2754,7 +2757,7 @@
                         <a:buNone/>
                       </a:pPr>
                       <a:r>
-                        <a:rPr lang="en-US" sz="1000" dirty="0">
+                        <a:rPr lang="en-US" sz="950" dirty="0">
                           <a:solidFill>
                             <a:srgbClr val="000000"/>
                           </a:solidFill>
@@ -2762,9 +2765,9 @@
                           <a:ea typeface="Segoe UI" pitchFamily="34" charset="-122"/>
                           <a:cs typeface="Segoe UI" pitchFamily="34" charset="-120"/>
                         </a:rPr>
-                        <a:t>Cross-Origin CORS Access Blocks</a:t>
+                        <a:t>Blocked CORS Domain Access</a:t>
                       </a:r>
-                      <a:endParaRPr lang="en-US" sz="1000" dirty="0">
+                      <a:endParaRPr lang="en-US" sz="950" dirty="0">
                         <a:latin typeface="Segoe UI" charset="0"/>
                         <a:ea typeface="Segoe UI" charset="0"/>
                         <a:cs typeface="Segoe UI" charset="0"/>
@@ -2819,7 +2822,7 @@
                         <a:buNone/>
                       </a:pPr>
                       <a:r>
-                        <a:rPr lang="en-US" sz="1000" dirty="0">
+                        <a:rPr lang="en-US" sz="950" dirty="0">
                           <a:solidFill>
                             <a:srgbClr val="000000"/>
                           </a:solidFill>
@@ -2827,9 +2830,9 @@
                           <a:ea typeface="Segoe UI" pitchFamily="34" charset="-122"/>
                           <a:cs typeface="Segoe UI" pitchFamily="34" charset="-120"/>
                         </a:rPr>
-                        <a:t>Serving frontend via Vercel, gateway on Railway, and CDN on Cloudinary caused CORS request rejections.</a:t>
+                        <a:t>Deploying clients on Vercel and gateways on Railway caused browser security blocks.</a:t>
                       </a:r>
-                      <a:endParaRPr lang="en-US" sz="1000" dirty="0">
+                      <a:endParaRPr lang="en-US" sz="950" dirty="0">
                         <a:latin typeface="Segoe UI" charset="0"/>
                         <a:ea typeface="Segoe UI" charset="0"/>
                         <a:cs typeface="Segoe UI" charset="0"/>
@@ -2884,7 +2887,7 @@
                         <a:buNone/>
                       </a:pPr>
                       <a:r>
-                        <a:rPr lang="en-US" sz="1000" dirty="0">
+                        <a:rPr lang="en-US" sz="950" dirty="0">
                           <a:solidFill>
                             <a:srgbClr val="000000"/>
                           </a:solidFill>
@@ -2892,9 +2895,9 @@
                           <a:ea typeface="Segoe UI" pitchFamily="34" charset="-122"/>
                           <a:cs typeface="Segoe UI" pitchFamily="34" charset="-120"/>
                         </a:rPr>
-                        <a:t>Implemented dynamic CORS options inside the Express application configurations to securely authorize client headers.</a:t>
+                        <a:t>Applied dynamic Express CORS middleware configurations to authorize custom client headers.</a:t>
                       </a:r>
-                      <a:endParaRPr lang="en-US" sz="1000" dirty="0">
+                      <a:endParaRPr lang="en-US" sz="950" dirty="0">
                         <a:latin typeface="Segoe UI" charset="0"/>
                         <a:ea typeface="Segoe UI" charset="0"/>
                         <a:cs typeface="Segoe UI" charset="0"/>
@@ -2995,7 +2998,7 @@
               <a:buNone/>
             </a:pPr>
             <a:r>
-              <a:rPr lang="en-US" sz="2800" b="1" dirty="0">
+              <a:rPr lang="en-US" sz="2600" b="1" dirty="0">
                 <a:solidFill>
                   <a:srgbClr val="2563EB"/>
                 </a:solidFill>
@@ -3003,9 +3006,9 @@
                 <a:ea typeface="Segoe UI" pitchFamily="34" charset="-122"/>
                 <a:cs typeface="Segoe UI" pitchFamily="34" charset="-120"/>
               </a:rPr>
-              <a:t>Live Testing Flow</a:t>
-            </a:r>
-            <a:endParaRPr lang="en-US" sz="2800" dirty="0"/>
+              <a:t>Scalability Roadmap</a:t>
+            </a:r>
+            <a:endParaRPr lang="en-US" sz="2600" dirty="0"/>
           </a:p>
         </p:txBody>
       </p:sp>
@@ -3017,8 +3020,8 @@
         </p:nvSpPr>
         <p:spPr>
           <a:xfrm>
-            <a:off x="731520" y="1005840"/>
-            <a:ext cx="7772400" cy="365760"/>
+            <a:off x="731520" y="1188720"/>
+            <a:ext cx="7680960" cy="3200400"/>
           </a:xfrm>
           <a:prstGeom prst="rect">
             <a:avLst/>
@@ -3034,70 +3037,36 @@
               <a:buNone/>
             </a:pPr>
             <a:r>
-              <a:rPr lang="en-US" sz="1300" dirty="0">
-                <a:solidFill>
-                  <a:srgbClr val="64748B"/>
-                </a:solidFill>
-                <a:latin typeface="Segoe UI" pitchFamily="34" charset="0"/>
-                <a:ea typeface="Segoe UI" pitchFamily="34" charset="-122"/>
-                <a:cs typeface="Segoe UI" pitchFamily="34" charset="-120"/>
-              </a:rPr>
-              <a:t>Step-by-step walk-through utilizing built-in guest login shortcuts:</a:t>
-            </a:r>
-            <a:endParaRPr lang="en-US" sz="1300" dirty="0"/>
-          </a:p>
-        </p:txBody>
-      </p:sp>
-      <p:sp>
-        <p:nvSpPr>
-          <p:cNvPr id="4" name="Shape 2"/>
-          <p:cNvSpPr/>
-          <p:nvPr/>
-        </p:nvSpPr>
-        <p:spPr>
-          <a:xfrm>
-            <a:off x="731520" y="1463040"/>
-            <a:ext cx="7680960" cy="640080"/>
-          </a:xfrm>
-          <a:prstGeom prst="rect">
-            <a:avLst/>
-          </a:prstGeom>
-          <a:solidFill>
-            <a:srgbClr val="F8FAFC"/>
-          </a:solidFill>
-          <a:ln w="12700">
-            <a:solidFill>
-              <a:srgbClr val="E2E8F0"/>
-            </a:solidFill>
-            <a:prstDash val="solid"/>
-          </a:ln>
-        </p:spPr>
-      </p:sp>
-      <p:sp>
-        <p:nvSpPr>
-          <p:cNvPr id="5" name="Text 3"/>
-          <p:cNvSpPr/>
-          <p:nvPr/>
-        </p:nvSpPr>
-        <p:spPr>
-          <a:xfrm>
-            <a:off x="914400" y="1600200"/>
-            <a:ext cx="2011680" cy="365760"/>
-          </a:xfrm>
-          <a:prstGeom prst="rect">
-            <a:avLst/>
-          </a:prstGeom>
-          <a:noFill/>
-          <a:ln/>
-        </p:spPr>
-        <p:txBody>
-          <a:bodyPr wrap="square" rtlCol="0" anchor="ctr"/>
-          <a:lstStyle/>
-          <a:p>
+              <a:rPr lang="en-US" sz="1200" b="1" dirty="0">
+                <a:solidFill>
+                  <a:srgbClr val="2563EB"/>
+                </a:solidFill>
+                <a:latin typeface="Segoe UI" pitchFamily="34" charset="0"/>
+                <a:ea typeface="Segoe UI" pitchFamily="34" charset="-122"/>
+                <a:cs typeface="Segoe UI" pitchFamily="34" charset="-120"/>
+              </a:rPr>
+              <a:t>• Redis Cache-Aside Pattern:
+</a:t>
+            </a:r>
             <a:pPr indent="0" marL="0">
               <a:buNone/>
             </a:pPr>
             <a:r>
+              <a:rPr lang="en-US" sz="1200" dirty="0">
+                <a:solidFill>
+                  <a:srgbClr val="1E293B"/>
+                </a:solidFill>
+                <a:latin typeface="Segoe UI" pitchFamily="34" charset="0"/>
+                <a:ea typeface="Segoe UI" pitchFamily="34" charset="-122"/>
+                <a:cs typeface="Segoe UI" pitchFamily="34" charset="-120"/>
+              </a:rPr>
+              <a:t>  Add an in-memory Redis cache for doctors list and schedules. Reduces database query loads by up to 80%.
+</a:t>
+            </a:r>
+            <a:pPr indent="0" marL="0">
+              <a:buNone/>
+            </a:pPr>
+            <a:r>
               <a:rPr lang="en-US" sz="1200" b="1" dirty="0">
                 <a:solidFill>
                   <a:srgbClr val="2563EB"/>
@@ -3106,357 +3075,54 @@
                 <a:ea typeface="Segoe UI" pitchFamily="34" charset="-122"/>
                 <a:cs typeface="Segoe UI" pitchFamily="34" charset="-120"/>
               </a:rPr>
-              <a:t>1. Guest Access</a:t>
+              <a:t>• Asynchronous Task Queues:
+</a:t>
+            </a:r>
+            <a:pPr indent="0" marL="0">
+              <a:buNone/>
+            </a:pPr>
+            <a:r>
+              <a:rPr lang="en-US" sz="1200" dirty="0">
+                <a:solidFill>
+                  <a:srgbClr val="1E293B"/>
+                </a:solidFill>
+                <a:latin typeface="Segoe UI" pitchFamily="34" charset="0"/>
+                <a:ea typeface="Segoe UI" pitchFamily="34" charset="-122"/>
+                <a:cs typeface="Segoe UI" pitchFamily="34" charset="-120"/>
+              </a:rPr>
+              <a:t>  Move OCR uploads to background queues (like BullMQ) using Redis, letting users book slots immediately.
+</a:t>
+            </a:r>
+            <a:pPr indent="0" marL="0">
+              <a:buNone/>
+            </a:pPr>
+            <a:r>
+              <a:rPr lang="en-US" sz="1200" b="1" dirty="0">
+                <a:solidFill>
+                  <a:srgbClr val="2563EB"/>
+                </a:solidFill>
+                <a:latin typeface="Segoe UI" pitchFamily="34" charset="0"/>
+                <a:ea typeface="Segoe UI" pitchFamily="34" charset="-122"/>
+                <a:cs typeface="Segoe UI" pitchFamily="34" charset="-120"/>
+              </a:rPr>
+              <a:t>• Container Containment:
+</a:t>
+            </a:r>
+            <a:pPr indent="0" marL="0">
+              <a:buNone/>
+            </a:pPr>
+            <a:r>
+              <a:rPr lang="en-US" sz="1200" dirty="0">
+                <a:solidFill>
+                  <a:srgbClr val="1E293B"/>
+                </a:solidFill>
+                <a:latin typeface="Segoe UI" pitchFamily="34" charset="0"/>
+                <a:ea typeface="Segoe UI" pitchFamily="34" charset="-122"/>
+                <a:cs typeface="Segoe UI" pitchFamily="34" charset="-120"/>
+              </a:rPr>
+              <a:t>  Package services inside Docker containers for reliable scaling and seamless cloud deployment.</a:t>
             </a:r>
             <a:endParaRPr lang="en-US" sz="1200" dirty="0"/>
-          </a:p>
-        </p:txBody>
-      </p:sp>
-      <p:sp>
-        <p:nvSpPr>
-          <p:cNvPr id="6" name="Text 4"/>
-          <p:cNvSpPr/>
-          <p:nvPr/>
-        </p:nvSpPr>
-        <p:spPr>
-          <a:xfrm>
-            <a:off x="3017520" y="1600200"/>
-            <a:ext cx="5212080" cy="365760"/>
-          </a:xfrm>
-          <a:prstGeom prst="rect">
-            <a:avLst/>
-          </a:prstGeom>
-          <a:noFill/>
-          <a:ln/>
-        </p:spPr>
-        <p:txBody>
-          <a:bodyPr wrap="square" rtlCol="0" anchor="ctr"/>
-          <a:lstStyle/>
-          <a:p>
-            <a:pPr indent="0" marL="0">
-              <a:buNone/>
-            </a:pPr>
-            <a:r>
-              <a:rPr lang="en-US" sz="1000" dirty="0">
-                <a:solidFill>
-                  <a:srgbClr val="1E293B"/>
-                </a:solidFill>
-                <a:latin typeface="Segoe UI" pitchFamily="34" charset="0"/>
-                <a:ea typeface="Segoe UI" pitchFamily="34" charset="-122"/>
-                <a:cs typeface="Segoe UI" pitchFamily="34" charset="-120"/>
-              </a:rPr>
-              <a:t>Click 'One-Click Login as Demo Patient' at /user/login. OTP code 123456 will pre-fill dynamically.</a:t>
-            </a:r>
-            <a:endParaRPr lang="en-US" sz="1000" dirty="0"/>
-          </a:p>
-        </p:txBody>
-      </p:sp>
-      <p:sp>
-        <p:nvSpPr>
-          <p:cNvPr id="7" name="Shape 5"/>
-          <p:cNvSpPr/>
-          <p:nvPr/>
-        </p:nvSpPr>
-        <p:spPr>
-          <a:xfrm>
-            <a:off x="731520" y="2240280"/>
-            <a:ext cx="7680960" cy="640080"/>
-          </a:xfrm>
-          <a:prstGeom prst="rect">
-            <a:avLst/>
-          </a:prstGeom>
-          <a:solidFill>
-            <a:srgbClr val="F8FAFC"/>
-          </a:solidFill>
-          <a:ln w="12700">
-            <a:solidFill>
-              <a:srgbClr val="E2E8F0"/>
-            </a:solidFill>
-            <a:prstDash val="solid"/>
-          </a:ln>
-        </p:spPr>
-      </p:sp>
-      <p:sp>
-        <p:nvSpPr>
-          <p:cNvPr id="8" name="Text 6"/>
-          <p:cNvSpPr/>
-          <p:nvPr/>
-        </p:nvSpPr>
-        <p:spPr>
-          <a:xfrm>
-            <a:off x="914400" y="2377440"/>
-            <a:ext cx="2011680" cy="365760"/>
-          </a:xfrm>
-          <a:prstGeom prst="rect">
-            <a:avLst/>
-          </a:prstGeom>
-          <a:noFill/>
-          <a:ln/>
-        </p:spPr>
-        <p:txBody>
-          <a:bodyPr wrap="square" rtlCol="0" anchor="ctr"/>
-          <a:lstStyle/>
-          <a:p>
-            <a:pPr indent="0" marL="0">
-              <a:buNone/>
-            </a:pPr>
-            <a:r>
-              <a:rPr lang="en-US" sz="1200" b="1" dirty="0">
-                <a:solidFill>
-                  <a:srgbClr val="2563EB"/>
-                </a:solidFill>
-                <a:latin typeface="Segoe UI" pitchFamily="34" charset="0"/>
-                <a:ea typeface="Segoe UI" pitchFamily="34" charset="-122"/>
-                <a:cs typeface="Segoe UI" pitchFamily="34" charset="-120"/>
-              </a:rPr>
-              <a:t>2. Document Vetting</a:t>
-            </a:r>
-            <a:endParaRPr lang="en-US" sz="1200" dirty="0"/>
-          </a:p>
-        </p:txBody>
-      </p:sp>
-      <p:sp>
-        <p:nvSpPr>
-          <p:cNvPr id="9" name="Text 7"/>
-          <p:cNvSpPr/>
-          <p:nvPr/>
-        </p:nvSpPr>
-        <p:spPr>
-          <a:xfrm>
-            <a:off x="3017520" y="2377440"/>
-            <a:ext cx="5212080" cy="365760"/>
-          </a:xfrm>
-          <a:prstGeom prst="rect">
-            <a:avLst/>
-          </a:prstGeom>
-          <a:noFill/>
-          <a:ln/>
-        </p:spPr>
-        <p:txBody>
-          <a:bodyPr wrap="square" rtlCol="0" anchor="ctr"/>
-          <a:lstStyle/>
-          <a:p>
-            <a:pPr indent="0" marL="0">
-              <a:buNone/>
-            </a:pPr>
-            <a:r>
-              <a:rPr lang="en-US" sz="1000" dirty="0">
-                <a:solidFill>
-                  <a:srgbClr val="1E293B"/>
-                </a:solidFill>
-                <a:latin typeface="Segoe UI" pitchFamily="34" charset="0"/>
-                <a:ea typeface="Segoe UI" pitchFamily="34" charset="-122"/>
-                <a:cs typeface="Segoe UI" pitchFamily="34" charset="-120"/>
-              </a:rPr>
-              <a:t>Go to the dashboard, upload a clinical file, and check how the OCR worker filters specialists.</a:t>
-            </a:r>
-            <a:endParaRPr lang="en-US" sz="1000" dirty="0"/>
-          </a:p>
-        </p:txBody>
-      </p:sp>
-      <p:sp>
-        <p:nvSpPr>
-          <p:cNvPr id="10" name="Shape 8"/>
-          <p:cNvSpPr/>
-          <p:nvPr/>
-        </p:nvSpPr>
-        <p:spPr>
-          <a:xfrm>
-            <a:off x="731520" y="3017520"/>
-            <a:ext cx="7680960" cy="640080"/>
-          </a:xfrm>
-          <a:prstGeom prst="rect">
-            <a:avLst/>
-          </a:prstGeom>
-          <a:solidFill>
-            <a:srgbClr val="F8FAFC"/>
-          </a:solidFill>
-          <a:ln w="12700">
-            <a:solidFill>
-              <a:srgbClr val="E2E8F0"/>
-            </a:solidFill>
-            <a:prstDash val="solid"/>
-          </a:ln>
-        </p:spPr>
-      </p:sp>
-      <p:sp>
-        <p:nvSpPr>
-          <p:cNvPr id="11" name="Text 9"/>
-          <p:cNvSpPr/>
-          <p:nvPr/>
-        </p:nvSpPr>
-        <p:spPr>
-          <a:xfrm>
-            <a:off x="914400" y="3154680"/>
-            <a:ext cx="2011680" cy="365760"/>
-          </a:xfrm>
-          <a:prstGeom prst="rect">
-            <a:avLst/>
-          </a:prstGeom>
-          <a:noFill/>
-          <a:ln/>
-        </p:spPr>
-        <p:txBody>
-          <a:bodyPr wrap="square" rtlCol="0" anchor="ctr"/>
-          <a:lstStyle/>
-          <a:p>
-            <a:pPr indent="0" marL="0">
-              <a:buNone/>
-            </a:pPr>
-            <a:r>
-              <a:rPr lang="en-US" sz="1200" b="1" dirty="0">
-                <a:solidFill>
-                  <a:srgbClr val="2563EB"/>
-                </a:solidFill>
-                <a:latin typeface="Segoe UI" pitchFamily="34" charset="0"/>
-                <a:ea typeface="Segoe UI" pitchFamily="34" charset="-122"/>
-                <a:cs typeface="Segoe UI" pitchFamily="34" charset="-120"/>
-              </a:rPr>
-              <a:t>3. Booking &amp; Escrow</a:t>
-            </a:r>
-            <a:endParaRPr lang="en-US" sz="1200" dirty="0"/>
-          </a:p>
-        </p:txBody>
-      </p:sp>
-      <p:sp>
-        <p:nvSpPr>
-          <p:cNvPr id="12" name="Text 10"/>
-          <p:cNvSpPr/>
-          <p:nvPr/>
-        </p:nvSpPr>
-        <p:spPr>
-          <a:xfrm>
-            <a:off x="3017520" y="3154680"/>
-            <a:ext cx="5212080" cy="365760"/>
-          </a:xfrm>
-          <a:prstGeom prst="rect">
-            <a:avLst/>
-          </a:prstGeom>
-          <a:noFill/>
-          <a:ln/>
-        </p:spPr>
-        <p:txBody>
-          <a:bodyPr wrap="square" rtlCol="0" anchor="ctr"/>
-          <a:lstStyle/>
-          <a:p>
-            <a:pPr indent="0" marL="0">
-              <a:buNone/>
-            </a:pPr>
-            <a:r>
-              <a:rPr lang="en-US" sz="1000" dirty="0">
-                <a:solidFill>
-                  <a:srgbClr val="1E293B"/>
-                </a:solidFill>
-                <a:latin typeface="Segoe UI" pitchFamily="34" charset="0"/>
-                <a:ea typeface="Segoe UI" pitchFamily="34" charset="-122"/>
-                <a:cs typeface="Segoe UI" pitchFamily="34" charset="-120"/>
-              </a:rPr>
-              <a:t>Select a slot. The database lock triggers, showing a 'Held' status on the admin panel.</a:t>
-            </a:r>
-            <a:endParaRPr lang="en-US" sz="1000" dirty="0"/>
-          </a:p>
-        </p:txBody>
-      </p:sp>
-      <p:sp>
-        <p:nvSpPr>
-          <p:cNvPr id="13" name="Shape 11"/>
-          <p:cNvSpPr/>
-          <p:nvPr/>
-        </p:nvSpPr>
-        <p:spPr>
-          <a:xfrm>
-            <a:off x="731520" y="3794760"/>
-            <a:ext cx="7680960" cy="640080"/>
-          </a:xfrm>
-          <a:prstGeom prst="rect">
-            <a:avLst/>
-          </a:prstGeom>
-          <a:solidFill>
-            <a:srgbClr val="F8FAFC"/>
-          </a:solidFill>
-          <a:ln w="12700">
-            <a:solidFill>
-              <a:srgbClr val="E2E8F0"/>
-            </a:solidFill>
-            <a:prstDash val="solid"/>
-          </a:ln>
-        </p:spPr>
-      </p:sp>
-      <p:sp>
-        <p:nvSpPr>
-          <p:cNvPr id="14" name="Text 12"/>
-          <p:cNvSpPr/>
-          <p:nvPr/>
-        </p:nvSpPr>
-        <p:spPr>
-          <a:xfrm>
-            <a:off x="914400" y="3931920"/>
-            <a:ext cx="2011680" cy="365760"/>
-          </a:xfrm>
-          <a:prstGeom prst="rect">
-            <a:avLst/>
-          </a:prstGeom>
-          <a:noFill/>
-          <a:ln/>
-        </p:spPr>
-        <p:txBody>
-          <a:bodyPr wrap="square" rtlCol="0" anchor="ctr"/>
-          <a:lstStyle/>
-          <a:p>
-            <a:pPr indent="0" marL="0">
-              <a:buNone/>
-            </a:pPr>
-            <a:r>
-              <a:rPr lang="en-US" sz="1200" b="1" dirty="0">
-                <a:solidFill>
-                  <a:srgbClr val="2563EB"/>
-                </a:solidFill>
-                <a:latin typeface="Segoe UI" pitchFamily="34" charset="0"/>
-                <a:ea typeface="Segoe UI" pitchFamily="34" charset="-122"/>
-                <a:cs typeface="Segoe UI" pitchFamily="34" charset="-120"/>
-              </a:rPr>
-              <a:t>4. Escrow Release</a:t>
-            </a:r>
-            <a:endParaRPr lang="en-US" sz="1200" dirty="0"/>
-          </a:p>
-        </p:txBody>
-      </p:sp>
-      <p:sp>
-        <p:nvSpPr>
-          <p:cNvPr id="15" name="Text 13"/>
-          <p:cNvSpPr/>
-          <p:nvPr/>
-        </p:nvSpPr>
-        <p:spPr>
-          <a:xfrm>
-            <a:off x="3017520" y="3931920"/>
-            <a:ext cx="5212080" cy="365760"/>
-          </a:xfrm>
-          <a:prstGeom prst="rect">
-            <a:avLst/>
-          </a:prstGeom>
-          <a:noFill/>
-          <a:ln/>
-        </p:spPr>
-        <p:txBody>
-          <a:bodyPr wrap="square" rtlCol="0" anchor="ctr"/>
-          <a:lstStyle/>
-          <a:p>
-            <a:pPr indent="0" marL="0">
-              <a:buNone/>
-            </a:pPr>
-            <a:r>
-              <a:rPr lang="en-US" sz="1000" dirty="0">
-                <a:solidFill>
-                  <a:srgbClr val="1E293B"/>
-                </a:solidFill>
-                <a:latin typeface="Segoe UI" pitchFamily="34" charset="0"/>
-                <a:ea typeface="Segoe UI" pitchFamily="34" charset="-122"/>
-                <a:cs typeface="Segoe UI" pitchFamily="34" charset="-120"/>
-              </a:rPr>
-              <a:t>Log in as Dr. Smith via doctor portal. Accept appointment and write a prescription to trigger ledger payout.</a:t>
-            </a:r>
-            <a:endParaRPr lang="en-US" sz="1000" dirty="0"/>
           </a:p>
         </p:txBody>
       </p:sp>
@@ -3510,7 +3176,7 @@
               <a:buNone/>
             </a:pPr>
             <a:r>
-              <a:rPr lang="en-US" sz="2800" b="1" dirty="0">
+              <a:rPr lang="en-US" sz="2600" b="1" dirty="0">
                 <a:solidFill>
                   <a:srgbClr val="2563EB"/>
                 </a:solidFill>
@@ -3518,9 +3184,9 @@
                 <a:ea typeface="Segoe UI" pitchFamily="34" charset="-122"/>
                 <a:cs typeface="Segoe UI" pitchFamily="34" charset="-120"/>
               </a:rPr>
-              <a:t>Scale Roadmap &amp; Engineering Takeaways</a:t>
-            </a:r>
-            <a:endParaRPr lang="en-US" sz="2800" dirty="0"/>
+              <a:t>Live Demo Flow</a:t>
+            </a:r>
+            <a:endParaRPr lang="en-US" sz="2600" dirty="0"/>
           </a:p>
         </p:txBody>
       </p:sp>
@@ -3532,8 +3198,8 @@
         </p:nvSpPr>
         <p:spPr>
           <a:xfrm>
-            <a:off x="731520" y="1280160"/>
-            <a:ext cx="7680960" cy="3108960"/>
+            <a:off x="731520" y="914400"/>
+            <a:ext cx="7772400" cy="365760"/>
           </a:xfrm>
           <a:prstGeom prst="rect">
             <a:avLst/>
@@ -3549,6 +3215,70 @@
               <a:buNone/>
             </a:pPr>
             <a:r>
+              <a:rPr lang="en-US" sz="1300" dirty="0">
+                <a:solidFill>
+                  <a:srgbClr val="64748B"/>
+                </a:solidFill>
+                <a:latin typeface="Segoe UI" pitchFamily="34" charset="0"/>
+                <a:ea typeface="Segoe UI" pitchFamily="34" charset="-122"/>
+                <a:cs typeface="Segoe UI" pitchFamily="34" charset="-120"/>
+              </a:rPr>
+              <a:t>Showcase end-to-end interactions with these simple guest login steps:</a:t>
+            </a:r>
+            <a:endParaRPr lang="en-US" sz="1300" dirty="0"/>
+          </a:p>
+        </p:txBody>
+      </p:sp>
+      <p:sp>
+        <p:nvSpPr>
+          <p:cNvPr id="4" name="Shape 2"/>
+          <p:cNvSpPr/>
+          <p:nvPr/>
+        </p:nvSpPr>
+        <p:spPr>
+          <a:xfrm>
+            <a:off x="731520" y="1371600"/>
+            <a:ext cx="7680960" cy="640080"/>
+          </a:xfrm>
+          <a:prstGeom prst="rect">
+            <a:avLst/>
+          </a:prstGeom>
+          <a:solidFill>
+            <a:srgbClr val="F8FAFC"/>
+          </a:solidFill>
+          <a:ln w="12700">
+            <a:solidFill>
+              <a:srgbClr val="E2E8F0"/>
+            </a:solidFill>
+            <a:prstDash val="solid"/>
+          </a:ln>
+        </p:spPr>
+      </p:sp>
+      <p:sp>
+        <p:nvSpPr>
+          <p:cNvPr id="5" name="Text 3"/>
+          <p:cNvSpPr/>
+          <p:nvPr/>
+        </p:nvSpPr>
+        <p:spPr>
+          <a:xfrm>
+            <a:off x="914400" y="1508760"/>
+            <a:ext cx="1828800" cy="365760"/>
+          </a:xfrm>
+          <a:prstGeom prst="rect">
+            <a:avLst/>
+          </a:prstGeom>
+          <a:noFill/>
+          <a:ln/>
+        </p:spPr>
+        <p:txBody>
+          <a:bodyPr wrap="square" rtlCol="0" anchor="ctr"/>
+          <a:lstStyle/>
+          <a:p>
+            <a:pPr indent="0" marL="0">
+              <a:buNone/>
+            </a:pPr>
+            <a:r>
               <a:rPr lang="en-US" sz="1200" b="1" dirty="0">
                 <a:solidFill>
                   <a:srgbClr val="2563EB"/>
@@ -3557,14 +3287,38 @@
                 <a:ea typeface="Segoe UI" pitchFamily="34" charset="-122"/>
                 <a:cs typeface="Segoe UI" pitchFamily="34" charset="-120"/>
               </a:rPr>
-              <a:t>• Redis Cache-Aside Pattern:
-</a:t>
-            </a:r>
+              <a:t>1. One-Click Login</a:t>
+            </a:r>
+            <a:endParaRPr lang="en-US" sz="1200" dirty="0"/>
+          </a:p>
+        </p:txBody>
+      </p:sp>
+      <p:sp>
+        <p:nvSpPr>
+          <p:cNvPr id="6" name="Text 4"/>
+          <p:cNvSpPr/>
+          <p:nvPr/>
+        </p:nvSpPr>
+        <p:spPr>
+          <a:xfrm>
+            <a:off x="2926080" y="1508760"/>
+            <a:ext cx="5303520" cy="365760"/>
+          </a:xfrm>
+          <a:prstGeom prst="rect">
+            <a:avLst/>
+          </a:prstGeom>
+          <a:noFill/>
+          <a:ln/>
+        </p:spPr>
+        <p:txBody>
+          <a:bodyPr wrap="square" rtlCol="0" anchor="ctr"/>
+          <a:lstStyle/>
+          <a:p>
             <a:pPr indent="0" marL="0">
               <a:buNone/>
             </a:pPr>
             <a:r>
-              <a:rPr lang="en-US" sz="1200" dirty="0">
+              <a:rPr lang="en-US" sz="1000" dirty="0">
                 <a:solidFill>
                   <a:srgbClr val="1E293B"/>
                 </a:solidFill>
@@ -3572,9 +3326,58 @@
                 <a:ea typeface="Segoe UI" pitchFamily="34" charset="-122"/>
                 <a:cs typeface="Segoe UI" pitchFamily="34" charset="-120"/>
               </a:rPr>
-              <a:t>  Integrating Redis to cache public doctor directories and slots would reduce database query loads by up to 80%.
-</a:t>
-            </a:r>
+              <a:t>Click 'One-Click Login as Demo Patient' at /user/login. OTP bypass code 123456 will pre-fill.</a:t>
+            </a:r>
+            <a:endParaRPr lang="en-US" sz="1000" dirty="0"/>
+          </a:p>
+        </p:txBody>
+      </p:sp>
+      <p:sp>
+        <p:nvSpPr>
+          <p:cNvPr id="7" name="Shape 5"/>
+          <p:cNvSpPr/>
+          <p:nvPr/>
+        </p:nvSpPr>
+        <p:spPr>
+          <a:xfrm>
+            <a:off x="731520" y="2148840"/>
+            <a:ext cx="7680960" cy="640080"/>
+          </a:xfrm>
+          <a:prstGeom prst="rect">
+            <a:avLst/>
+          </a:prstGeom>
+          <a:solidFill>
+            <a:srgbClr val="F8FAFC"/>
+          </a:solidFill>
+          <a:ln w="12700">
+            <a:solidFill>
+              <a:srgbClr val="E2E8F0"/>
+            </a:solidFill>
+            <a:prstDash val="solid"/>
+          </a:ln>
+        </p:spPr>
+      </p:sp>
+      <p:sp>
+        <p:nvSpPr>
+          <p:cNvPr id="8" name="Text 6"/>
+          <p:cNvSpPr/>
+          <p:nvPr/>
+        </p:nvSpPr>
+        <p:spPr>
+          <a:xfrm>
+            <a:off x="914400" y="2286000"/>
+            <a:ext cx="1828800" cy="365760"/>
+          </a:xfrm>
+          <a:prstGeom prst="rect">
+            <a:avLst/>
+          </a:prstGeom>
+          <a:noFill/>
+          <a:ln/>
+        </p:spPr>
+        <p:txBody>
+          <a:bodyPr wrap="square" rtlCol="0" anchor="ctr"/>
+          <a:lstStyle/>
+          <a:p>
             <a:pPr indent="0" marL="0">
               <a:buNone/>
             </a:pPr>
@@ -3587,14 +3390,38 @@
                 <a:ea typeface="Segoe UI" pitchFamily="34" charset="-122"/>
                 <a:cs typeface="Segoe UI" pitchFamily="34" charset="-120"/>
               </a:rPr>
-              <a:t>• Message Broker Integration:
-</a:t>
-            </a:r>
+              <a:t>2. Upload &amp; Triage</a:t>
+            </a:r>
+            <a:endParaRPr lang="en-US" sz="1200" dirty="0"/>
+          </a:p>
+        </p:txBody>
+      </p:sp>
+      <p:sp>
+        <p:nvSpPr>
+          <p:cNvPr id="9" name="Text 7"/>
+          <p:cNvSpPr/>
+          <p:nvPr/>
+        </p:nvSpPr>
+        <p:spPr>
+          <a:xfrm>
+            <a:off x="2926080" y="2286000"/>
+            <a:ext cx="5303520" cy="365760"/>
+          </a:xfrm>
+          <a:prstGeom prst="rect">
+            <a:avLst/>
+          </a:prstGeom>
+          <a:noFill/>
+          <a:ln/>
+        </p:spPr>
+        <p:txBody>
+          <a:bodyPr wrap="square" rtlCol="0" anchor="ctr"/>
+          <a:lstStyle/>
+          <a:p>
             <a:pPr indent="0" marL="0">
               <a:buNone/>
             </a:pPr>
             <a:r>
-              <a:rPr lang="en-US" sz="1200" dirty="0">
+              <a:rPr lang="en-US" sz="1000" dirty="0">
                 <a:solidFill>
                   <a:srgbClr val="1E293B"/>
                 </a:solidFill>
@@ -3602,9 +3429,58 @@
                 <a:ea typeface="Segoe UI" pitchFamily="34" charset="-122"/>
                 <a:cs typeface="Segoe UI" pitchFamily="34" charset="-120"/>
               </a:rPr>
-              <a:t>  Replacing direct API calls for OCR with a Redis-backed BullMQ message queue to handle uploads asynchronously.
-</a:t>
-            </a:r>
+              <a:t>Go to the dashboard, upload a medical report, and check the automatic specialty filter.</a:t>
+            </a:r>
+            <a:endParaRPr lang="en-US" sz="1000" dirty="0"/>
+          </a:p>
+        </p:txBody>
+      </p:sp>
+      <p:sp>
+        <p:nvSpPr>
+          <p:cNvPr id="10" name="Shape 8"/>
+          <p:cNvSpPr/>
+          <p:nvPr/>
+        </p:nvSpPr>
+        <p:spPr>
+          <a:xfrm>
+            <a:off x="731520" y="2926080"/>
+            <a:ext cx="7680960" cy="640080"/>
+          </a:xfrm>
+          <a:prstGeom prst="rect">
+            <a:avLst/>
+          </a:prstGeom>
+          <a:solidFill>
+            <a:srgbClr val="F8FAFC"/>
+          </a:solidFill>
+          <a:ln w="12700">
+            <a:solidFill>
+              <a:srgbClr val="E2E8F0"/>
+            </a:solidFill>
+            <a:prstDash val="solid"/>
+          </a:ln>
+        </p:spPr>
+      </p:sp>
+      <p:sp>
+        <p:nvSpPr>
+          <p:cNvPr id="11" name="Text 9"/>
+          <p:cNvSpPr/>
+          <p:nvPr/>
+        </p:nvSpPr>
+        <p:spPr>
+          <a:xfrm>
+            <a:off x="914400" y="3063240"/>
+            <a:ext cx="1828800" cy="365760"/>
+          </a:xfrm>
+          <a:prstGeom prst="rect">
+            <a:avLst/>
+          </a:prstGeom>
+          <a:noFill/>
+          <a:ln/>
+        </p:spPr>
+        <p:txBody>
+          <a:bodyPr wrap="square" rtlCol="0" anchor="ctr"/>
+          <a:lstStyle/>
+          <a:p>
             <a:pPr indent="0" marL="0">
               <a:buNone/>
             </a:pPr>
@@ -3617,14 +3493,38 @@
                 <a:ea typeface="Segoe UI" pitchFamily="34" charset="-122"/>
                 <a:cs typeface="Segoe UI" pitchFamily="34" charset="-120"/>
               </a:rPr>
-              <a:t>• Core Learning - Service Decoupling:
-</a:t>
-            </a:r>
+              <a:t>3. Confirm Booking</a:t>
+            </a:r>
+            <a:endParaRPr lang="en-US" sz="1200" dirty="0"/>
+          </a:p>
+        </p:txBody>
+      </p:sp>
+      <p:sp>
+        <p:nvSpPr>
+          <p:cNvPr id="12" name="Text 10"/>
+          <p:cNvSpPr/>
+          <p:nvPr/>
+        </p:nvSpPr>
+        <p:spPr>
+          <a:xfrm>
+            <a:off x="2926080" y="3063240"/>
+            <a:ext cx="5303520" cy="365760"/>
+          </a:xfrm>
+          <a:prstGeom prst="rect">
+            <a:avLst/>
+          </a:prstGeom>
+          <a:noFill/>
+          <a:ln/>
+        </p:spPr>
+        <p:txBody>
+          <a:bodyPr wrap="square" rtlCol="0" anchor="ctr"/>
+          <a:lstStyle/>
+          <a:p>
             <a:pPr indent="0" marL="0">
               <a:buNone/>
             </a:pPr>
             <a:r>
-              <a:rPr lang="en-US" sz="1200" dirty="0">
+              <a:rPr lang="en-US" sz="1000" dirty="0">
                 <a:solidFill>
                   <a:srgbClr val="1E293B"/>
                 </a:solidFill>
@@ -3632,9 +3532,112 @@
                 <a:ea typeface="Segoe UI" pitchFamily="34" charset="-122"/>
                 <a:cs typeface="Segoe UI" pitchFamily="34" charset="-120"/>
               </a:rPr>
-              <a:t>  Isolating heavy operations keeps HTTP gateways responsive. Centralizing fixes makes systems maintainable.</a:t>
+              <a:t>Select a slot. The database lock applies, showing 'Held' payment state.</a:t>
+            </a:r>
+            <a:endParaRPr lang="en-US" sz="1000" dirty="0"/>
+          </a:p>
+        </p:txBody>
+      </p:sp>
+      <p:sp>
+        <p:nvSpPr>
+          <p:cNvPr id="13" name="Shape 11"/>
+          <p:cNvSpPr/>
+          <p:nvPr/>
+        </p:nvSpPr>
+        <p:spPr>
+          <a:xfrm>
+            <a:off x="731520" y="3703320"/>
+            <a:ext cx="7680960" cy="640080"/>
+          </a:xfrm>
+          <a:prstGeom prst="rect">
+            <a:avLst/>
+          </a:prstGeom>
+          <a:solidFill>
+            <a:srgbClr val="F8FAFC"/>
+          </a:solidFill>
+          <a:ln w="12700">
+            <a:solidFill>
+              <a:srgbClr val="E2E8F0"/>
+            </a:solidFill>
+            <a:prstDash val="solid"/>
+          </a:ln>
+        </p:spPr>
+      </p:sp>
+      <p:sp>
+        <p:nvSpPr>
+          <p:cNvPr id="14" name="Text 12"/>
+          <p:cNvSpPr/>
+          <p:nvPr/>
+        </p:nvSpPr>
+        <p:spPr>
+          <a:xfrm>
+            <a:off x="914400" y="3840480"/>
+            <a:ext cx="1828800" cy="365760"/>
+          </a:xfrm>
+          <a:prstGeom prst="rect">
+            <a:avLst/>
+          </a:prstGeom>
+          <a:noFill/>
+          <a:ln/>
+        </p:spPr>
+        <p:txBody>
+          <a:bodyPr wrap="square" rtlCol="0" anchor="ctr"/>
+          <a:lstStyle/>
+          <a:p>
+            <a:pPr indent="0" marL="0">
+              <a:buNone/>
+            </a:pPr>
+            <a:r>
+              <a:rPr lang="en-US" sz="1200" b="1" dirty="0">
+                <a:solidFill>
+                  <a:srgbClr val="2563EB"/>
+                </a:solidFill>
+                <a:latin typeface="Segoe UI" pitchFamily="34" charset="0"/>
+                <a:ea typeface="Segoe UI" pitchFamily="34" charset="-122"/>
+                <a:cs typeface="Segoe UI" pitchFamily="34" charset="-120"/>
+              </a:rPr>
+              <a:t>4. Release Payout</a:t>
             </a:r>
             <a:endParaRPr lang="en-US" sz="1200" dirty="0"/>
+          </a:p>
+        </p:txBody>
+      </p:sp>
+      <p:sp>
+        <p:nvSpPr>
+          <p:cNvPr id="15" name="Text 13"/>
+          <p:cNvSpPr/>
+          <p:nvPr/>
+        </p:nvSpPr>
+        <p:spPr>
+          <a:xfrm>
+            <a:off x="2926080" y="3840480"/>
+            <a:ext cx="5303520" cy="365760"/>
+          </a:xfrm>
+          <a:prstGeom prst="rect">
+            <a:avLst/>
+          </a:prstGeom>
+          <a:noFill/>
+          <a:ln/>
+        </p:spPr>
+        <p:txBody>
+          <a:bodyPr wrap="square" rtlCol="0" anchor="ctr"/>
+          <a:lstStyle/>
+          <a:p>
+            <a:pPr indent="0" marL="0">
+              <a:buNone/>
+            </a:pPr>
+            <a:r>
+              <a:rPr lang="en-US" sz="1000" dirty="0">
+                <a:solidFill>
+                  <a:srgbClr val="1E293B"/>
+                </a:solidFill>
+                <a:latin typeface="Segoe UI" pitchFamily="34" charset="0"/>
+                <a:ea typeface="Segoe UI" pitchFamily="34" charset="-122"/>
+                <a:cs typeface="Segoe UI" pitchFamily="34" charset="-120"/>
+              </a:rPr>
+              <a:t>Log in as doctor via dr_smith. Accept appointment and prescribe medicine to trigger doctor payout.</a:t>
+            </a:r>
+            <a:endParaRPr lang="en-US" sz="1000" dirty="0"/>
           </a:p>
         </p:txBody>
       </p:sp>
@@ -3688,7 +3691,7 @@
               <a:buNone/>
             </a:pPr>
             <a:r>
-              <a:rPr lang="en-US" sz="2800" b="1" dirty="0">
+              <a:rPr lang="en-US" sz="2600" b="1" dirty="0">
                 <a:solidFill>
                   <a:srgbClr val="2563EB"/>
                 </a:solidFill>
@@ -3696,9 +3699,9 @@
                 <a:ea typeface="Segoe UI" pitchFamily="34" charset="-122"/>
                 <a:cs typeface="Segoe UI" pitchFamily="34" charset="-120"/>
               </a:rPr>
-              <a:t>The Healthcare Engineering Void</a:t>
-            </a:r>
-            <a:endParaRPr lang="en-US" sz="2800" dirty="0"/>
+              <a:t>The Problems We Are Solving</a:t>
+            </a:r>
+            <a:endParaRPr lang="en-US" sz="2600" dirty="0"/>
           </a:p>
         </p:txBody>
       </p:sp>
@@ -3710,7 +3713,7 @@
         </p:nvSpPr>
         <p:spPr>
           <a:xfrm>
-            <a:off x="731520" y="1005840"/>
+            <a:off x="731520" y="914400"/>
             <a:ext cx="7772400" cy="365760"/>
           </a:xfrm>
           <a:prstGeom prst="rect">
@@ -3735,7 +3738,7 @@
                 <a:ea typeface="Segoe UI" pitchFamily="34" charset="-122"/>
                 <a:cs typeface="Segoe UI" pitchFamily="34" charset="-120"/>
               </a:rPr>
-              <a:t>Root causes of architectural failure in traditional healthcare booking networks:</a:t>
+              <a:t>Why traditional appointment systems are difficult to build and run:</a:t>
             </a:r>
             <a:endParaRPr lang="en-US" sz="1300" dirty="0"/>
           </a:p>
@@ -3749,8 +3752,8 @@
         </p:nvSpPr>
         <p:spPr>
           <a:xfrm>
-            <a:off x="731520" y="1554480"/>
-            <a:ext cx="2423160" cy="2926080"/>
+            <a:off x="731520" y="1463040"/>
+            <a:ext cx="2423160" cy="3017520"/>
           </a:xfrm>
           <a:prstGeom prst="rect">
             <a:avLst/>
@@ -3774,7 +3777,7 @@
         </p:nvSpPr>
         <p:spPr>
           <a:xfrm>
-            <a:off x="868680" y="1737360"/>
+            <a:off x="868680" y="1645920"/>
             <a:ext cx="2148840" cy="365760"/>
           </a:xfrm>
           <a:prstGeom prst="rect">
@@ -3791,7 +3794,7 @@
               <a:buNone/>
             </a:pPr>
             <a:r>
-              <a:rPr lang="en-US" sz="1400" b="1" dirty="0">
+              <a:rPr lang="en-US" sz="1300" b="1" dirty="0">
                 <a:solidFill>
                   <a:srgbClr val="2563EB"/>
                 </a:solidFill>
@@ -3799,9 +3802,9 @@
                 <a:ea typeface="Segoe UI" pitchFamily="34" charset="-122"/>
                 <a:cs typeface="Segoe UI" pitchFamily="34" charset="-120"/>
               </a:rPr>
-              <a:t>1. Slot Concurrency Overlaps</a:t>
-            </a:r>
-            <a:endParaRPr lang="en-US" sz="1400" dirty="0"/>
+              <a:t>Double Booking Slots</a:t>
+            </a:r>
+            <a:endParaRPr lang="en-US" sz="1300" dirty="0"/>
           </a:p>
         </p:txBody>
       </p:sp>
@@ -3813,8 +3816,8 @@
         </p:nvSpPr>
         <p:spPr>
           <a:xfrm>
-            <a:off x="868680" y="2194560"/>
-            <a:ext cx="2148840" cy="2011680"/>
+            <a:off x="868680" y="2103120"/>
+            <a:ext cx="2148840" cy="2103120"/>
           </a:xfrm>
           <a:prstGeom prst="rect">
             <a:avLst/>
@@ -3838,7 +3841,7 @@
                 <a:ea typeface="Segoe UI" pitchFamily="34" charset="-122"/>
                 <a:cs typeface="Segoe UI" pitchFamily="34" charset="-120"/>
               </a:rPr>
-              <a:t>Naive database updates cause double-bookings. Under high-throughput conditions, race conditions violate scheduling constraints.</a:t>
+              <a:t>Two users click the same appointment slot simultaneously. Without proper locks on the database level, both get booked, leading to schedule conflicts.</a:t>
             </a:r>
             <a:endParaRPr lang="en-US" sz="1100" dirty="0"/>
           </a:p>
@@ -3852,8 +3855,8 @@
         </p:nvSpPr>
         <p:spPr>
           <a:xfrm>
-            <a:off x="3337560" y="1554480"/>
-            <a:ext cx="2423160" cy="2926080"/>
+            <a:off x="3337560" y="1463040"/>
+            <a:ext cx="2423160" cy="3017520"/>
           </a:xfrm>
           <a:prstGeom prst="rect">
             <a:avLst/>
@@ -3877,7 +3880,7 @@
         </p:nvSpPr>
         <p:spPr>
           <a:xfrm>
-            <a:off x="3474720" y="1737360"/>
+            <a:off x="3474720" y="1645920"/>
             <a:ext cx="2148840" cy="365760"/>
           </a:xfrm>
           <a:prstGeom prst="rect">
@@ -3894,7 +3897,7 @@
               <a:buNone/>
             </a:pPr>
             <a:r>
-              <a:rPr lang="en-US" sz="1400" b="1" dirty="0">
+              <a:rPr lang="en-US" sz="1300" b="1" dirty="0">
                 <a:solidFill>
                   <a:srgbClr val="2563EB"/>
                 </a:solidFill>
@@ -3902,9 +3905,9 @@
                 <a:ea typeface="Segoe UI" pitchFamily="34" charset="-122"/>
                 <a:cs typeface="Segoe UI" pitchFamily="34" charset="-120"/>
               </a:rPr>
-              <a:t>2. Monolithic Blocking Spikes</a:t>
-            </a:r>
-            <a:endParaRPr lang="en-US" sz="1400" dirty="0"/>
+              <a:t>Main Server Slowdown</a:t>
+            </a:r>
+            <a:endParaRPr lang="en-US" sz="1300" dirty="0"/>
           </a:p>
         </p:txBody>
       </p:sp>
@@ -3916,8 +3919,8 @@
         </p:nvSpPr>
         <p:spPr>
           <a:xfrm>
-            <a:off x="3474720" y="2194560"/>
-            <a:ext cx="2148840" cy="2011680"/>
+            <a:off x="3474720" y="2103120"/>
+            <a:ext cx="2148840" cy="2103120"/>
           </a:xfrm>
           <a:prstGeom prst="rect">
             <a:avLst/>
@@ -3941,7 +3944,7 @@
                 <a:ea typeface="Segoe UI" pitchFamily="34" charset="-122"/>
                 <a:cs typeface="Segoe UI" pitchFamily="34" charset="-120"/>
               </a:rPr>
-              <a:t>Executing Tesseract OCR inline inside the main API thread freezes the Node.js event-loop, causing severe gateway latency spikes.</a:t>
+              <a:t>Reading text from files (OCR) takes a lot of CPU power. Running this directly on the main Node server freezes it and delays requests for all other users.</a:t>
             </a:r>
             <a:endParaRPr lang="en-US" sz="1100" dirty="0"/>
           </a:p>
@@ -3955,8 +3958,8 @@
         </p:nvSpPr>
         <p:spPr>
           <a:xfrm>
-            <a:off x="5943600" y="1554480"/>
-            <a:ext cx="2423160" cy="2926080"/>
+            <a:off x="5943600" y="1463040"/>
+            <a:ext cx="2423160" cy="3017520"/>
           </a:xfrm>
           <a:prstGeom prst="rect">
             <a:avLst/>
@@ -3980,7 +3983,7 @@
         </p:nvSpPr>
         <p:spPr>
           <a:xfrm>
-            <a:off x="6080760" y="1737360"/>
+            <a:off x="6080760" y="1645920"/>
             <a:ext cx="2148840" cy="365760"/>
           </a:xfrm>
           <a:prstGeom prst="rect">
@@ -3997,7 +4000,7 @@
               <a:buNone/>
             </a:pPr>
             <a:r>
-              <a:rPr lang="en-US" sz="1400" b="1" dirty="0">
+              <a:rPr lang="en-US" sz="1300" b="1" dirty="0">
                 <a:solidFill>
                   <a:srgbClr val="2563EB"/>
                 </a:solidFill>
@@ -4005,9 +4008,9 @@
                 <a:ea typeface="Segoe UI" pitchFamily="34" charset="-122"/>
                 <a:cs typeface="Segoe UI" pitchFamily="34" charset="-120"/>
               </a:rPr>
-              <a:t>3. Disk Storage Exhaustion</a:t>
-            </a:r>
-            <a:endParaRPr lang="en-US" sz="1400" dirty="0"/>
+              <a:t>Running Out of Disk Space</a:t>
+            </a:r>
+            <a:endParaRPr lang="en-US" sz="1300" dirty="0"/>
           </a:p>
         </p:txBody>
       </p:sp>
@@ -4019,8 +4022,8 @@
         </p:nvSpPr>
         <p:spPr>
           <a:xfrm>
-            <a:off x="6080760" y="2194560"/>
-            <a:ext cx="2148840" cy="2011680"/>
+            <a:off x="6080760" y="2103120"/>
+            <a:ext cx="2148840" cy="2103120"/>
           </a:xfrm>
           <a:prstGeom prst="rect">
             <a:avLst/>
@@ -4044,7 +4047,7 @@
                 <a:ea typeface="Segoe UI" pitchFamily="34" charset="-122"/>
                 <a:cs typeface="Segoe UI" pitchFamily="34" charset="-120"/>
               </a:rPr>
-              <a:t>Raw PDF and image uploads stored directly on ephemeral container nodes degrade container lifespan and trigger cluster crashes.</a:t>
+              <a:t>Storing large medical reports and images directly on the application servers fills up disk storage quickly and slows down server performance.</a:t>
             </a:r>
             <a:endParaRPr lang="en-US" sz="1100" dirty="0"/>
           </a:p>
@@ -4100,7 +4103,7 @@
               <a:buNone/>
             </a:pPr>
             <a:r>
-              <a:rPr lang="en-US" sz="2800" b="1" dirty="0">
+              <a:rPr lang="en-US" sz="2600" b="1" dirty="0">
                 <a:solidFill>
                   <a:srgbClr val="2563EB"/>
                 </a:solidFill>
@@ -4108,9 +4111,9 @@
                 <a:ea typeface="Segoe UI" pitchFamily="34" charset="-122"/>
                 <a:cs typeface="Segoe UI" pitchFamily="34" charset="-120"/>
               </a:rPr>
-              <a:t>The Technical Resolution</a:t>
-            </a:r>
-            <a:endParaRPr lang="en-US" sz="2800" dirty="0"/>
+              <a:t>System Requirements</a:t>
+            </a:r>
+            <a:endParaRPr lang="en-US" sz="2600" dirty="0"/>
           </a:p>
         </p:txBody>
       </p:sp>
@@ -4123,7 +4126,7 @@
         <p:spPr>
           <a:xfrm>
             <a:off x="731520" y="1188720"/>
-            <a:ext cx="7680960" cy="1005840"/>
+            <a:ext cx="3657600" cy="3200400"/>
           </a:xfrm>
           <a:prstGeom prst="rect">
             <a:avLst/>
@@ -4147,8 +4150,8 @@
         </p:nvSpPr>
         <p:spPr>
           <a:xfrm>
-            <a:off x="914400" y="1325880"/>
-            <a:ext cx="7315200" cy="274320"/>
+            <a:off x="914400" y="1371600"/>
+            <a:ext cx="3291840" cy="365760"/>
           </a:xfrm>
           <a:prstGeom prst="rect">
             <a:avLst/>
@@ -4172,7 +4175,7 @@
                 <a:ea typeface="Segoe UI" pitchFamily="34" charset="-122"/>
                 <a:cs typeface="Segoe UI" pitchFamily="34" charset="-120"/>
               </a:rPr>
-              <a:t>Decoupled Processing Workers</a:t>
+              <a:t>What the System Does</a:t>
             </a:r>
             <a:endParaRPr lang="en-US" sz="1400" dirty="0"/>
           </a:p>
@@ -4186,8 +4189,8 @@
         </p:nvSpPr>
         <p:spPr>
           <a:xfrm>
-            <a:off x="914400" y="1600200"/>
-            <a:ext cx="7315200" cy="457200"/>
+            <a:off x="914400" y="1828800"/>
+            <a:ext cx="3291840" cy="2377440"/>
           </a:xfrm>
           <a:prstGeom prst="rect">
             <a:avLst/>
@@ -4203,6 +4206,20 @@
               <a:buNone/>
             </a:pPr>
             <a:r>
+              <a:rPr lang="en-US" sz="1100" b="1" dirty="0">
+                <a:solidFill>
+                  <a:srgbClr val="2563EB"/>
+                </a:solidFill>
+                <a:latin typeface="Segoe UI" pitchFamily="34" charset="0"/>
+                <a:ea typeface="Segoe UI" pitchFamily="34" charset="-122"/>
+                <a:cs typeface="Segoe UI" pitchFamily="34" charset="-120"/>
+              </a:rPr>
+              <a:t>• Patients: </a:t>
+            </a:r>
+            <a:pPr indent="0" marL="0">
+              <a:buNone/>
+            </a:pPr>
+            <a:r>
               <a:rPr lang="en-US" sz="1100" dirty="0">
                 <a:solidFill>
                   <a:srgbClr val="1E293B"/>
@@ -4211,7 +4228,65 @@
                 <a:ea typeface="Segoe UI" pitchFamily="34" charset="-122"/>
                 <a:cs typeface="Segoe UI" pitchFamily="34" charset="-120"/>
               </a:rPr>
-              <a:t>Heavy file uploads and image processing are delegated to isolated microservice nodes, protecting the API gateway.</a:t>
+              <a:t>Scan reports, search specialists, book slots, and pay.
+</a:t>
+            </a:r>
+            <a:pPr indent="0" marL="0">
+              <a:buNone/>
+            </a:pPr>
+            <a:r>
+              <a:rPr lang="en-US" sz="1100" b="1" dirty="0">
+                <a:solidFill>
+                  <a:srgbClr val="2563EB"/>
+                </a:solidFill>
+                <a:latin typeface="Segoe UI" pitchFamily="34" charset="0"/>
+                <a:ea typeface="Segoe UI" pitchFamily="34" charset="-122"/>
+                <a:cs typeface="Segoe UI" pitchFamily="34" charset="-120"/>
+              </a:rPr>
+              <a:t>• Doctors: </a:t>
+            </a:r>
+            <a:pPr indent="0" marL="0">
+              <a:buNone/>
+            </a:pPr>
+            <a:r>
+              <a:rPr lang="en-US" sz="1100" dirty="0">
+                <a:solidFill>
+                  <a:srgbClr val="1E293B"/>
+                </a:solidFill>
+                <a:latin typeface="Segoe UI" pitchFamily="34" charset="0"/>
+                <a:ea typeface="Segoe UI" pitchFamily="34" charset="-122"/>
+                <a:cs typeface="Segoe UI" pitchFamily="34" charset="-120"/>
+              </a:rPr>
+              <a:t>Set slot availability, approve bookings, write prescriptions.
+</a:t>
+            </a:r>
+            <a:pPr indent="0" marL="0">
+              <a:buNone/>
+            </a:pPr>
+            <a:r>
+              <a:rPr lang="en-US" sz="1100" b="1" dirty="0">
+                <a:solidFill>
+                  <a:srgbClr val="2563EB"/>
+                </a:solidFill>
+                <a:latin typeface="Segoe UI" pitchFamily="34" charset="0"/>
+                <a:ea typeface="Segoe UI" pitchFamily="34" charset="-122"/>
+                <a:cs typeface="Segoe UI" pitchFamily="34" charset="-120"/>
+              </a:rPr>
+              <a:t>• Pharmacy: </a:t>
+            </a:r>
+            <a:pPr indent="0" marL="0">
+              <a:buNone/>
+            </a:pPr>
+            <a:r>
+              <a:rPr lang="en-US" sz="1100" dirty="0">
+                <a:solidFill>
+                  <a:srgbClr val="1E293B"/>
+                </a:solidFill>
+                <a:latin typeface="Segoe UI" pitchFamily="34" charset="0"/>
+                <a:ea typeface="Segoe UI" pitchFamily="34" charset="-122"/>
+                <a:cs typeface="Segoe UI" pitchFamily="34" charset="-120"/>
+              </a:rPr>
+              <a:t>Receive order notifications, fulfill medicines, view wallet earnings.</a:t>
             </a:r>
             <a:endParaRPr lang="en-US" sz="1100" dirty="0"/>
           </a:p>
@@ -4225,8 +4300,8 @@
         </p:nvSpPr>
         <p:spPr>
           <a:xfrm>
-            <a:off x="731520" y="2331720"/>
-            <a:ext cx="7680960" cy="1005840"/>
+            <a:off x="4754880" y="1188720"/>
+            <a:ext cx="3657600" cy="3200400"/>
           </a:xfrm>
           <a:prstGeom prst="rect">
             <a:avLst/>
@@ -4250,8 +4325,8 @@
         </p:nvSpPr>
         <p:spPr>
           <a:xfrm>
-            <a:off x="914400" y="2468880"/>
-            <a:ext cx="7315200" cy="274320"/>
+            <a:off x="4937760" y="1371600"/>
+            <a:ext cx="3291840" cy="365760"/>
           </a:xfrm>
           <a:prstGeom prst="rect">
             <a:avLst/>
@@ -4275,7 +4350,7 @@
                 <a:ea typeface="Segoe UI" pitchFamily="34" charset="-122"/>
                 <a:cs typeface="Segoe UI" pitchFamily="34" charset="-120"/>
               </a:rPr>
-              <a:t>Pessimistic DB Lease-Locks</a:t>
+              <a:t>How the System Behaves</a:t>
             </a:r>
             <a:endParaRPr lang="en-US" sz="1400" dirty="0"/>
           </a:p>
@@ -4289,8 +4364,8 @@
         </p:nvSpPr>
         <p:spPr>
           <a:xfrm>
-            <a:off x="914400" y="2743200"/>
-            <a:ext cx="7315200" cy="457200"/>
+            <a:off x="4937760" y="1828800"/>
+            <a:ext cx="3291840" cy="2377440"/>
           </a:xfrm>
           <a:prstGeom prst="rect">
             <a:avLst/>
@@ -4306,6 +4381,20 @@
               <a:buNone/>
             </a:pPr>
             <a:r>
+              <a:rPr lang="en-US" sz="1100" b="1" dirty="0">
+                <a:solidFill>
+                  <a:srgbClr val="2563EB"/>
+                </a:solidFill>
+                <a:latin typeface="Segoe UI" pitchFamily="34" charset="0"/>
+                <a:ea typeface="Segoe UI" pitchFamily="34" charset="-122"/>
+                <a:cs typeface="Segoe UI" pitchFamily="34" charset="-120"/>
+              </a:rPr>
+              <a:t>• Zero Double-Booking: </a:t>
+            </a:r>
+            <a:pPr indent="0" marL="0">
+              <a:buNone/>
+            </a:pPr>
+            <a:r>
               <a:rPr lang="en-US" sz="1100" dirty="0">
                 <a:solidFill>
                   <a:srgbClr val="1E293B"/>
@@ -4314,63 +4403,14 @@
                 <a:ea typeface="Segoe UI" pitchFamily="34" charset="-122"/>
                 <a:cs typeface="Segoe UI" pitchFamily="34" charset="-120"/>
               </a:rPr>
-              <a:t>A robust 10-minute transaction lock is placed in Postgres for slots, preventing simultaneous bookings while verifying payments.</a:t>
-            </a:r>
-            <a:endParaRPr lang="en-US" sz="1100" dirty="0"/>
-          </a:p>
-        </p:txBody>
-      </p:sp>
-      <p:sp>
-        <p:nvSpPr>
-          <p:cNvPr id="9" name="Shape 7"/>
-          <p:cNvSpPr/>
-          <p:nvPr/>
-        </p:nvSpPr>
-        <p:spPr>
-          <a:xfrm>
-            <a:off x="731520" y="3474720"/>
-            <a:ext cx="7680960" cy="1005840"/>
-          </a:xfrm>
-          <a:prstGeom prst="rect">
-            <a:avLst/>
-          </a:prstGeom>
-          <a:solidFill>
-            <a:srgbClr val="F8FAFC"/>
-          </a:solidFill>
-          <a:ln w="12700">
-            <a:solidFill>
-              <a:srgbClr val="E2E8F0"/>
-            </a:solidFill>
-            <a:prstDash val="solid"/>
-          </a:ln>
-        </p:spPr>
-      </p:sp>
-      <p:sp>
-        <p:nvSpPr>
-          <p:cNvPr id="10" name="Text 8"/>
-          <p:cNvSpPr/>
-          <p:nvPr/>
-        </p:nvSpPr>
-        <p:spPr>
-          <a:xfrm>
-            <a:off x="914400" y="3611880"/>
-            <a:ext cx="7315200" cy="274320"/>
-          </a:xfrm>
-          <a:prstGeom prst="rect">
-            <a:avLst/>
-          </a:prstGeom>
-          <a:noFill/>
-          <a:ln/>
-        </p:spPr>
-        <p:txBody>
-          <a:bodyPr wrap="square" rtlCol="0" anchor="ctr"/>
-          <a:lstStyle/>
-          <a:p>
+              <a:t>Locks the slot instantly while payment is processing.
+</a:t>
+            </a:r>
             <a:pPr indent="0" marL="0">
               <a:buNone/>
             </a:pPr>
             <a:r>
-              <a:rPr lang="en-US" sz="1400" b="1" dirty="0">
+              <a:rPr lang="en-US" sz="1100" b="1" dirty="0">
                 <a:solidFill>
                   <a:srgbClr val="2563EB"/>
                 </a:solidFill>
@@ -4378,33 +4418,8 @@
                 <a:ea typeface="Segoe UI" pitchFamily="34" charset="-122"/>
                 <a:cs typeface="Segoe UI" pitchFamily="34" charset="-120"/>
               </a:rPr>
-              <a:t>Cryptographic Payout Escrow</a:t>
-            </a:r>
-            <a:endParaRPr lang="en-US" sz="1400" dirty="0"/>
-          </a:p>
-        </p:txBody>
-      </p:sp>
-      <p:sp>
-        <p:nvSpPr>
-          <p:cNvPr id="11" name="Text 9"/>
-          <p:cNvSpPr/>
-          <p:nvPr/>
-        </p:nvSpPr>
-        <p:spPr>
-          <a:xfrm>
-            <a:off x="914400" y="3886200"/>
-            <a:ext cx="7315200" cy="457200"/>
-          </a:xfrm>
-          <a:prstGeom prst="rect">
-            <a:avLst/>
-          </a:prstGeom>
-          <a:noFill/>
-          <a:ln/>
-        </p:spPr>
-        <p:txBody>
-          <a:bodyPr wrap="square" rtlCol="0" anchor="ctr"/>
-          <a:lstStyle/>
-          <a:p>
+              <a:t>• High Availability: </a:t>
+            </a:r>
             <a:pPr indent="0" marL="0">
               <a:buNone/>
             </a:pPr>
@@ -4417,7 +4432,36 @@
                 <a:ea typeface="Segoe UI" pitchFamily="34" charset="-122"/>
                 <a:cs typeface="Segoe UI" pitchFamily="34" charset="-120"/>
               </a:rPr>
-              <a:t>System balances are secured in escrow and only released to the doctor's wallet ledger upon upload of a valid prescription file.</a:t>
+              <a:t>Heavy text extraction runs on a separate backend container.
+</a:t>
+            </a:r>
+            <a:pPr indent="0" marL="0">
+              <a:buNone/>
+            </a:pPr>
+            <a:r>
+              <a:rPr lang="en-US" sz="1100" b="1" dirty="0">
+                <a:solidFill>
+                  <a:srgbClr val="2563EB"/>
+                </a:solidFill>
+                <a:latin typeface="Segoe UI" pitchFamily="34" charset="0"/>
+                <a:ea typeface="Segoe UI" pitchFamily="34" charset="-122"/>
+                <a:cs typeface="Segoe UI" pitchFamily="34" charset="-120"/>
+              </a:rPr>
+              <a:t>• Transaction Safety: </a:t>
+            </a:r>
+            <a:pPr indent="0" marL="0">
+              <a:buNone/>
+            </a:pPr>
+            <a:r>
+              <a:rPr lang="en-US" sz="1100" dirty="0">
+                <a:solidFill>
+                  <a:srgbClr val="1E293B"/>
+                </a:solidFill>
+                <a:latin typeface="Segoe UI" pitchFamily="34" charset="0"/>
+                <a:ea typeface="Segoe UI" pitchFamily="34" charset="-122"/>
+                <a:cs typeface="Segoe UI" pitchFamily="34" charset="-120"/>
+              </a:rPr>
+              <a:t>Holds patient payment in escrow. Payout occurs only on prescription.</a:t>
             </a:r>
             <a:endParaRPr lang="en-US" sz="1100" dirty="0"/>
           </a:p>
@@ -4473,7 +4517,7 @@
               <a:buNone/>
             </a:pPr>
             <a:r>
-              <a:rPr lang="en-US" sz="2800" b="1" dirty="0">
+              <a:rPr lang="en-US" sz="2600" b="1" dirty="0">
                 <a:solidFill>
                   <a:srgbClr val="2563EB"/>
                 </a:solidFill>
@@ -4481,9 +4525,9 @@
                 <a:ea typeface="Segoe UI" pitchFamily="34" charset="-122"/>
                 <a:cs typeface="Segoe UI" pitchFamily="34" charset="-120"/>
               </a:rPr>
-              <a:t>Technological Rationale</a:t>
-            </a:r>
-            <a:endParaRPr lang="en-US" sz="2800" dirty="0"/>
+              <a:t>Technology Stack Selection</a:t>
+            </a:r>
+            <a:endParaRPr lang="en-US" sz="2600" dirty="0"/>
           </a:p>
         </p:txBody>
       </p:sp>
@@ -4502,8 +4546,8 @@
           </p:nvPr>
         </p:nvGraphicFramePr>
         <p:xfrm>
-          <a:off x="731520" y="1188720"/>
-          <a:ext cx="7680960" cy="3200400"/>
+          <a:off x="731520" y="1097280"/>
+          <a:ext cx="7680960" cy="3291840"/>
         </p:xfrm>
         <a:graphic>
           <a:graphicData uri="http://schemas.openxmlformats.org/drawingml/2006/table">
@@ -4514,7 +4558,7 @@
                 <a:gridCol w="2560320"/>
                 <a:gridCol w="2560320"/>
               </a:tblGrid>
-              <a:tr h="533400">
+              <a:tr h="548640">
                 <a:tc>
                   <a:txBody>
                     <a:bodyPr/>
@@ -4532,7 +4576,7 @@
                           <a:ea typeface="Segoe UI" pitchFamily="34" charset="-122"/>
                           <a:cs typeface="Segoe UI" pitchFamily="34" charset="-120"/>
                         </a:rPr>
-                        <a:t>Technology Layer</a:t>
+                        <a:t>Layer</a:t>
                       </a:r>
                       <a:endParaRPr lang="en-US" sz="1000" dirty="0">
                         <a:latin typeface="Segoe UI" charset="0"/>
@@ -4600,7 +4644,7 @@
                           <a:ea typeface="Segoe UI" pitchFamily="34" charset="-122"/>
                           <a:cs typeface="Segoe UI" pitchFamily="34" charset="-120"/>
                         </a:rPr>
-                        <a:t>Selection Choice</a:t>
+                        <a:t>Choice</a:t>
                       </a:r>
                       <a:endParaRPr lang="en-US" sz="1000" dirty="0">
                         <a:latin typeface="Segoe UI" charset="0"/>
@@ -4668,7 +4712,7 @@
                           <a:ea typeface="Segoe UI" pitchFamily="34" charset="-122"/>
                           <a:cs typeface="Segoe UI" pitchFamily="34" charset="-120"/>
                         </a:rPr>
-                        <a:t>Engineering Rationale</a:t>
+                        <a:t>Justification</a:t>
                       </a:r>
                       <a:endParaRPr lang="en-US" sz="1000" dirty="0">
                         <a:latin typeface="Segoe UI" charset="0"/>
@@ -4720,7 +4764,7 @@
                   </a:tcPr>
                 </a:tc>
               </a:tr>
-              <a:tr h="533400">
+              <a:tr h="548640">
                 <a:tc>
                   <a:txBody>
                     <a:bodyPr/>
@@ -4738,7 +4782,7 @@
                           <a:ea typeface="Segoe UI" pitchFamily="34" charset="-122"/>
                           <a:cs typeface="Segoe UI" pitchFamily="34" charset="-120"/>
                         </a:rPr>
-                        <a:t>Frontend SPA</a:t>
+                        <a:t>Frontend UI</a:t>
                       </a:r>
                       <a:endParaRPr lang="en-US" sz="1000" dirty="0">
                         <a:latin typeface="Segoe UI" charset="0"/>
@@ -4803,7 +4847,7 @@
                           <a:ea typeface="Segoe UI" pitchFamily="34" charset="-122"/>
                           <a:cs typeface="Segoe UI" pitchFamily="34" charset="-120"/>
                         </a:rPr>
-                        <a:t>React.js (Vercel)</a:t>
+                        <a:t>React</a:t>
                       </a:r>
                       <a:endParaRPr lang="en-US" sz="1000" dirty="0">
                         <a:latin typeface="Segoe UI" charset="0"/>
@@ -4868,7 +4912,7 @@
                           <a:ea typeface="Segoe UI" pitchFamily="34" charset="-122"/>
                           <a:cs typeface="Segoe UI" pitchFamily="34" charset="-120"/>
                         </a:rPr>
-                        <a:t>Component-driven structure, stateless frontend route handling, optimized bundle serving via Vercel Edge networks.</a:t>
+                        <a:t>Builds highly interactive layouts easily. Renders data fast for responsive user dashboards.</a:t>
                       </a:r>
                       <a:endParaRPr lang="en-US" sz="1000" dirty="0">
                         <a:latin typeface="Segoe UI" charset="0"/>
@@ -4917,7 +4961,7 @@
                   </a:tcPr>
                 </a:tc>
               </a:tr>
-              <a:tr h="533400">
+              <a:tr h="548640">
                 <a:tc>
                   <a:txBody>
                     <a:bodyPr/>
@@ -4935,7 +4979,7 @@
                           <a:ea typeface="Segoe UI" pitchFamily="34" charset="-122"/>
                           <a:cs typeface="Segoe UI" pitchFamily="34" charset="-120"/>
                         </a:rPr>
-                        <a:t>API Gateway</a:t>
+                        <a:t>Main Server API</a:t>
                       </a:r>
                       <a:endParaRPr lang="en-US" sz="1000" dirty="0">
                         <a:latin typeface="Segoe UI" charset="0"/>
@@ -5000,7 +5044,7 @@
                           <a:ea typeface="Segoe UI" pitchFamily="34" charset="-122"/>
                           <a:cs typeface="Segoe UI" pitchFamily="34" charset="-120"/>
                         </a:rPr>
-                        <a:t>Node.js / Express (Railway)</a:t>
+                        <a:t>Node.js &amp; Express</a:t>
                       </a:r>
                       <a:endParaRPr lang="en-US" sz="1000" dirty="0">
                         <a:latin typeface="Segoe UI" charset="0"/>
@@ -5065,7 +5109,7 @@
                           <a:ea typeface="Segoe UI" pitchFamily="34" charset="-122"/>
                           <a:cs typeface="Segoe UI" pitchFamily="34" charset="-120"/>
                         </a:rPr>
-                        <a:t>Asynchronous, non-blocking I/O event loops ideal for high-concurrency request routing and validation.</a:t>
+                        <a:t>Handles many concurrent users at once because of its fast, non-blocking asynchronous event handler.</a:t>
                       </a:r>
                       <a:endParaRPr lang="en-US" sz="1000" dirty="0">
                         <a:latin typeface="Segoe UI" charset="0"/>
@@ -5114,7 +5158,7 @@
                   </a:tcPr>
                 </a:tc>
               </a:tr>
-              <a:tr h="533400">
+              <a:tr h="548640">
                 <a:tc>
                   <a:txBody>
                     <a:bodyPr/>
@@ -5132,7 +5176,7 @@
                           <a:ea typeface="Segoe UI" pitchFamily="34" charset="-122"/>
                           <a:cs typeface="Segoe UI" pitchFamily="34" charset="-120"/>
                         </a:rPr>
-                        <a:t>Relational DB</a:t>
+                        <a:t>Database</a:t>
                       </a:r>
                       <a:endParaRPr lang="en-US" sz="1000" dirty="0">
                         <a:latin typeface="Segoe UI" charset="0"/>
@@ -5197,7 +5241,7 @@
                           <a:ea typeface="Segoe UI" pitchFamily="34" charset="-122"/>
                           <a:cs typeface="Segoe UI" pitchFamily="34" charset="-120"/>
                         </a:rPr>
-                        <a:t>PostgreSQL (Neon Cloud)</a:t>
+                        <a:t>PostgreSQL (Neon)</a:t>
                       </a:r>
                       <a:endParaRPr lang="en-US" sz="1000" dirty="0">
                         <a:latin typeface="Segoe UI" charset="0"/>
@@ -5262,7 +5306,7 @@
                           <a:ea typeface="Segoe UI" pitchFamily="34" charset="-122"/>
                           <a:cs typeface="Segoe UI" pitchFamily="34" charset="-120"/>
                         </a:rPr>
-                        <a:t>ACID-compliant serverless database for strict financial data transactions and concurrent locking safety.</a:t>
+                        <a:t>Relational database with strict rules (ACID) to store clinic balances and slots safely.</a:t>
                       </a:r>
                       <a:endParaRPr lang="en-US" sz="1000" dirty="0">
                         <a:latin typeface="Segoe UI" charset="0"/>
@@ -5311,7 +5355,7 @@
                   </a:tcPr>
                 </a:tc>
               </a:tr>
-              <a:tr h="533400">
+              <a:tr h="548640">
                 <a:tc>
                   <a:txBody>
                     <a:bodyPr/>
@@ -5329,7 +5373,7 @@
                           <a:ea typeface="Segoe UI" pitchFamily="34" charset="-122"/>
                           <a:cs typeface="Segoe UI" pitchFamily="34" charset="-120"/>
                         </a:rPr>
-                        <a:t>Worker Node</a:t>
+                        <a:t>Text Scan Service</a:t>
                       </a:r>
                       <a:endParaRPr lang="en-US" sz="1000" dirty="0">
                         <a:latin typeface="Segoe UI" charset="0"/>
@@ -5394,7 +5438,7 @@
                           <a:ea typeface="Segoe UI" pitchFamily="34" charset="-122"/>
                           <a:cs typeface="Segoe UI" pitchFamily="34" charset="-120"/>
                         </a:rPr>
-                        <a:t>Python Flask (Railway)</a:t>
+                        <a:t>Python Flask</a:t>
                       </a:r>
                       <a:endParaRPr lang="en-US" sz="1000" dirty="0">
                         <a:latin typeface="Segoe UI" charset="0"/>
@@ -5459,7 +5503,7 @@
                           <a:ea typeface="Segoe UI" pitchFamily="34" charset="-122"/>
                           <a:cs typeface="Segoe UI" pitchFamily="34" charset="-120"/>
                         </a:rPr>
-                        <a:t>Lightweight container suited for CPU-heavy tasks like Tesseract OCR parsing and dictionary lookup.</a:t>
+                        <a:t>Separate OCR service so the main server stays fast and does not block public requests.</a:t>
                       </a:r>
                       <a:endParaRPr lang="en-US" sz="1000" dirty="0">
                         <a:latin typeface="Segoe UI" charset="0"/>
@@ -5508,7 +5552,7 @@
                   </a:tcPr>
                 </a:tc>
               </a:tr>
-              <a:tr h="533400">
+              <a:tr h="548640">
                 <a:tc>
                   <a:txBody>
                     <a:bodyPr/>
@@ -5526,7 +5570,7 @@
                           <a:ea typeface="Segoe UI" pitchFamily="34" charset="-122"/>
                           <a:cs typeface="Segoe UI" pitchFamily="34" charset="-120"/>
                         </a:rPr>
-                        <a:t>Stateless Storage</a:t>
+                        <a:t>File Cloud CDN</a:t>
                       </a:r>
                       <a:endParaRPr lang="en-US" sz="1000" dirty="0">
                         <a:latin typeface="Segoe UI" charset="0"/>
@@ -5591,7 +5635,7 @@
                           <a:ea typeface="Segoe UI" pitchFamily="34" charset="-122"/>
                           <a:cs typeface="Segoe UI" pitchFamily="34" charset="-120"/>
                         </a:rPr>
-                        <a:t>Cloudinary CDN</a:t>
+                        <a:t>Cloudinary</a:t>
                       </a:r>
                       <a:endParaRPr lang="en-US" sz="1000" dirty="0">
                         <a:latin typeface="Segoe UI" charset="0"/>
@@ -5656,7 +5700,7 @@
                           <a:ea typeface="Segoe UI" pitchFamily="34" charset="-122"/>
                           <a:cs typeface="Segoe UI" pitchFamily="34" charset="-120"/>
                         </a:rPr>
-                        <a:t>Offloads medical images/PDFs from the server containers, eliminating local disk write degradation.</a:t>
+                        <a:t>Stores user medical files in the cloud, saving local container disk space and removing storage limits.</a:t>
                       </a:r>
                       <a:endParaRPr lang="en-US" sz="1000" dirty="0">
                         <a:latin typeface="Segoe UI" charset="0"/>
@@ -5759,7 +5803,7 @@
               <a:buNone/>
             </a:pPr>
             <a:r>
-              <a:rPr lang="en-US" sz="2800" b="1" dirty="0">
+              <a:rPr lang="en-US" sz="2600" b="1" dirty="0">
                 <a:solidFill>
                   <a:srgbClr val="2563EB"/>
                 </a:solidFill>
@@ -5767,9 +5811,9 @@
                 <a:ea typeface="Segoe UI" pitchFamily="34" charset="-122"/>
                 <a:cs typeface="Segoe UI" pitchFamily="34" charset="-120"/>
               </a:rPr>
-              <a:t>High-Level Infrastructure Topology</a:t>
-            </a:r>
-            <a:endParaRPr lang="en-US" sz="2800" dirty="0"/>
+              <a:t>High-Level Architecture</a:t>
+            </a:r>
+            <a:endParaRPr lang="en-US" sz="2600" dirty="0"/>
           </a:p>
         </p:txBody>
       </p:sp>
@@ -5781,8 +5825,8 @@
         </p:nvSpPr>
         <p:spPr>
           <a:xfrm>
-            <a:off x="731520" y="1645920"/>
-            <a:ext cx="2011680" cy="1828800"/>
+            <a:off x="731520" y="1554480"/>
+            <a:ext cx="1920240" cy="1645920"/>
           </a:xfrm>
           <a:prstGeom prst="roundRect">
             <a:avLst/>
@@ -5806,8 +5850,8 @@
         </p:nvSpPr>
         <p:spPr>
           <a:xfrm>
-            <a:off x="822960" y="1737360"/>
-            <a:ext cx="1828800" cy="1645920"/>
+            <a:off x="822960" y="1645920"/>
+            <a:ext cx="1737360" cy="1463040"/>
           </a:xfrm>
           <a:prstGeom prst="rect">
             <a:avLst/>
@@ -5831,7 +5875,7 @@
                 <a:ea typeface="Segoe UI" pitchFamily="34" charset="-122"/>
                 <a:cs typeface="Segoe UI" pitchFamily="34" charset="-120"/>
               </a:rPr>
-              <a:t>React Web App</a:t>
+              <a:t>React Frontend</a:t>
             </a:r>
             <a:endParaRPr lang="en-US" sz="1100" dirty="0"/>
           </a:p>
@@ -5848,7 +5892,7 @@
                 <a:ea typeface="Segoe UI" pitchFamily="34" charset="-122"/>
                 <a:cs typeface="Segoe UI" pitchFamily="34" charset="-120"/>
               </a:rPr>
-              <a:t>(Vercel SPA)</a:t>
+              <a:t>(Client Web UI)</a:t>
             </a:r>
             <a:endParaRPr lang="en-US" sz="1100" dirty="0"/>
           </a:p>
@@ -5862,8 +5906,8 @@
         </p:nvSpPr>
         <p:spPr>
           <a:xfrm>
-            <a:off x="3200400" y="1645920"/>
-            <a:ext cx="2743200" cy="1828800"/>
+            <a:off x="3108960" y="1554480"/>
+            <a:ext cx="2743200" cy="1645920"/>
           </a:xfrm>
           <a:prstGeom prst="roundRect">
             <a:avLst/>
@@ -5887,8 +5931,8 @@
         </p:nvSpPr>
         <p:spPr>
           <a:xfrm>
-            <a:off x="3291840" y="1737360"/>
-            <a:ext cx="2560320" cy="1645920"/>
+            <a:off x="3200400" y="1645920"/>
+            <a:ext cx="2560320" cy="1463040"/>
           </a:xfrm>
           <a:prstGeom prst="rect">
             <a:avLst/>
@@ -5912,7 +5956,7 @@
                 <a:ea typeface="Segoe UI" pitchFamily="34" charset="-122"/>
                 <a:cs typeface="Segoe UI" pitchFamily="34" charset="-120"/>
               </a:rPr>
-              <a:t>Node.js Express Gateway</a:t>
+              <a:t>Node.js &amp; Express</a:t>
             </a:r>
             <a:endParaRPr lang="en-US" sz="1100" dirty="0"/>
           </a:p>
@@ -5929,7 +5973,7 @@
                 <a:ea typeface="Segoe UI" pitchFamily="34" charset="-122"/>
                 <a:cs typeface="Segoe UI" pitchFamily="34" charset="-120"/>
               </a:rPr>
-              <a:t>(Railway API)</a:t>
+              <a:t>(Main API Gateway)</a:t>
             </a:r>
             <a:endParaRPr lang="en-US" sz="1100" dirty="0"/>
           </a:p>
@@ -5943,8 +5987,8 @@
         </p:nvSpPr>
         <p:spPr>
           <a:xfrm>
-            <a:off x="6400800" y="1371600"/>
-            <a:ext cx="2011680" cy="1005840"/>
+            <a:off x="6309360" y="1371600"/>
+            <a:ext cx="2103120" cy="914400"/>
           </a:xfrm>
           <a:prstGeom prst="roundRect">
             <a:avLst/>
@@ -5968,8 +6012,8 @@
         </p:nvSpPr>
         <p:spPr>
           <a:xfrm>
-            <a:off x="6492240" y="1463040"/>
-            <a:ext cx="1828800" cy="822960"/>
+            <a:off x="6400800" y="1463040"/>
+            <a:ext cx="1920240" cy="731520"/>
           </a:xfrm>
           <a:prstGeom prst="rect">
             <a:avLst/>
@@ -5993,7 +6037,7 @@
                 <a:ea typeface="Segoe UI" pitchFamily="34" charset="-122"/>
                 <a:cs typeface="Segoe UI" pitchFamily="34" charset="-120"/>
               </a:rPr>
-              <a:t>Neon Postgres DB</a:t>
+              <a:t>Neon Postgres</a:t>
             </a:r>
             <a:endParaRPr lang="en-US" sz="1100" dirty="0"/>
           </a:p>
@@ -6010,7 +6054,7 @@
                 <a:ea typeface="Segoe UI" pitchFamily="34" charset="-122"/>
                 <a:cs typeface="Segoe UI" pitchFamily="34" charset="-120"/>
               </a:rPr>
-              <a:t>(ACID Store)</a:t>
+              <a:t>(Cloud Database)</a:t>
             </a:r>
             <a:endParaRPr lang="en-US" sz="1100" dirty="0"/>
           </a:p>
@@ -6024,8 +6068,8 @@
         </p:nvSpPr>
         <p:spPr>
           <a:xfrm>
-            <a:off x="6400800" y="2651760"/>
-            <a:ext cx="2011680" cy="1005840"/>
+            <a:off x="6309360" y="2560320"/>
+            <a:ext cx="2103120" cy="914400"/>
           </a:xfrm>
           <a:prstGeom prst="roundRect">
             <a:avLst/>
@@ -6049,8 +6093,8 @@
         </p:nvSpPr>
         <p:spPr>
           <a:xfrm>
-            <a:off x="6492240" y="2743200"/>
-            <a:ext cx="1828800" cy="822960"/>
+            <a:off x="6400800" y="2651760"/>
+            <a:ext cx="1920240" cy="731520"/>
           </a:xfrm>
           <a:prstGeom prst="rect">
             <a:avLst/>
@@ -6074,7 +6118,7 @@
                 <a:ea typeface="Segoe UI" pitchFamily="34" charset="-122"/>
                 <a:cs typeface="Segoe UI" pitchFamily="34" charset="-120"/>
               </a:rPr>
-              <a:t>Python OCR Worker</a:t>
+              <a:t>Python Flask</a:t>
             </a:r>
             <a:endParaRPr lang="en-US" sz="1100" dirty="0"/>
           </a:p>
@@ -6091,7 +6135,7 @@
                 <a:ea typeface="Segoe UI" pitchFamily="34" charset="-122"/>
                 <a:cs typeface="Segoe UI" pitchFamily="34" charset="-120"/>
               </a:rPr>
-              <a:t>(Tesseract Node)</a:t>
+              <a:t>(OCR Service)</a:t>
             </a:r>
             <a:endParaRPr lang="en-US" sz="1100" dirty="0"/>
           </a:p>
@@ -6105,7 +6149,7 @@
         </p:nvSpPr>
         <p:spPr>
           <a:xfrm>
-            <a:off x="731520" y="3840480"/>
+            <a:off x="731520" y="3749040"/>
             <a:ext cx="7680960" cy="731520"/>
           </a:xfrm>
           <a:prstGeom prst="rect">
@@ -6130,7 +6174,7 @@
                 <a:ea typeface="Segoe UI" pitchFamily="34" charset="-122"/>
                 <a:cs typeface="Segoe UI" pitchFamily="34" charset="-120"/>
               </a:rPr>
-              <a:t>• API Gateway: </a:t>
+              <a:t>• Request Pipeline: </a:t>
             </a:r>
             <a:pPr indent="0" marL="0">
               <a:buNone/>
@@ -6144,7 +6188,7 @@
                 <a:ea typeface="Segoe UI" pitchFamily="34" charset="-122"/>
                 <a:cs typeface="Segoe UI" pitchFamily="34" charset="-120"/>
               </a:rPr>
-              <a:t>Secures inputs via JWT, validates formats, and proxies CPU tasks.
+              <a:t>React client uploads a report -&gt; Node forwards it to Python Flask OCR -&gt; Flask returns triage department.
 </a:t>
             </a:r>
             <a:pPr indent="0" marL="0">
@@ -6173,7 +6217,7 @@
                 <a:ea typeface="Segoe UI" pitchFamily="34" charset="-122"/>
                 <a:cs typeface="Segoe UI" pitchFamily="34" charset="-120"/>
               </a:rPr>
-              <a:t>If the Python OCR worker experiences heavy load, the API gateway remains active.</a:t>
+              <a:t>Flask OCR is isolated. Even if OCR gets heavy traffic, patients can still browse slots without lag.</a:t>
             </a:r>
             <a:endParaRPr lang="en-US" sz="1100" dirty="0"/>
           </a:p>
@@ -6229,7 +6273,7 @@
               <a:buNone/>
             </a:pPr>
             <a:r>
-              <a:rPr lang="en-US" sz="2800" b="1" dirty="0">
+              <a:rPr lang="en-US" sz="2600" b="1" dirty="0">
                 <a:solidFill>
                   <a:srgbClr val="2563EB"/>
                 </a:solidFill>
@@ -6237,9 +6281,9 @@
                 <a:ea typeface="Segoe UI" pitchFamily="34" charset="-122"/>
                 <a:cs typeface="Segoe UI" pitchFamily="34" charset="-120"/>
               </a:rPr>
-              <a:t>Patient Request Lifecycle</a:t>
-            </a:r>
-            <a:endParaRPr lang="en-US" sz="2800" dirty="0"/>
+              <a:t>System Data Flow Lifecycle</a:t>
+            </a:r>
+            <a:endParaRPr lang="en-US" sz="2600" dirty="0"/>
           </a:p>
         </p:txBody>
       </p:sp>
@@ -6335,7 +6379,7 @@
                 <a:ea typeface="Segoe UI" pitchFamily="34" charset="-122"/>
                 <a:cs typeface="Segoe UI" pitchFamily="34" charset="-120"/>
               </a:rPr>
-              <a:t>Upload</a:t>
+              <a:t>Report Upload</a:t>
             </a:r>
             <a:endParaRPr lang="en-US" sz="1200" dirty="0"/>
           </a:p>
@@ -6374,7 +6418,7 @@
                 <a:ea typeface="Segoe UI" pitchFamily="34" charset="-122"/>
                 <a:cs typeface="Segoe UI" pitchFamily="34" charset="-120"/>
               </a:rPr>
-              <a:t>User uploads medical report</a:t>
+              <a:t>User uploads clinical prescription/file</a:t>
             </a:r>
             <a:endParaRPr lang="en-US" sz="900" dirty="0"/>
           </a:p>
@@ -6492,7 +6536,7 @@
                 <a:ea typeface="Segoe UI" pitchFamily="34" charset="-122"/>
                 <a:cs typeface="Segoe UI" pitchFamily="34" charset="-120"/>
               </a:rPr>
-              <a:t>OCR</a:t>
+              <a:t>OCR scan</a:t>
             </a:r>
             <a:endParaRPr lang="en-US" sz="1200" dirty="0"/>
           </a:p>
@@ -6531,7 +6575,7 @@
                 <a:ea typeface="Segoe UI" pitchFamily="34" charset="-122"/>
                 <a:cs typeface="Segoe UI" pitchFamily="34" charset="-120"/>
               </a:rPr>
-              <a:t>Tesseract extracts medical text</a:t>
+              <a:t>Python parses text and extracts tags</a:t>
             </a:r>
             <a:endParaRPr lang="en-US" sz="900" dirty="0"/>
           </a:p>
@@ -6649,7 +6693,7 @@
                 <a:ea typeface="Segoe UI" pitchFamily="34" charset="-122"/>
                 <a:cs typeface="Segoe UI" pitchFamily="34" charset="-120"/>
               </a:rPr>
-              <a:t>Triage</a:t>
+              <a:t>Specialty filter</a:t>
             </a:r>
             <a:endParaRPr lang="en-US" sz="1200" dirty="0"/>
           </a:p>
@@ -6688,7 +6732,7 @@
                 <a:ea typeface="Segoe UI" pitchFamily="34" charset="-122"/>
                 <a:cs typeface="Segoe UI" pitchFamily="34" charset="-120"/>
               </a:rPr>
-              <a:t>Keywords map to clinical specialties</a:t>
+              <a:t>System auto-filters the doctors board</a:t>
             </a:r>
             <a:endParaRPr lang="en-US" sz="900" dirty="0"/>
           </a:p>
@@ -6806,7 +6850,7 @@
                 <a:ea typeface="Segoe UI" pitchFamily="34" charset="-122"/>
                 <a:cs typeface="Segoe UI" pitchFamily="34" charset="-120"/>
               </a:rPr>
-              <a:t>Book</a:t>
+              <a:t>Lease lock</a:t>
             </a:r>
             <a:endParaRPr lang="en-US" sz="1200" dirty="0"/>
           </a:p>
@@ -6845,7 +6889,7 @@
                 <a:ea typeface="Segoe UI" pitchFamily="34" charset="-122"/>
                 <a:cs typeface="Segoe UI" pitchFamily="34" charset="-120"/>
               </a:rPr>
-              <a:t>Slots lock in database for 10 mins</a:t>
+              <a:t>Slot is locked in DB for 10 minutes</a:t>
             </a:r>
             <a:endParaRPr lang="en-US" sz="900" dirty="0"/>
           </a:p>
@@ -6963,7 +7007,7 @@
                 <a:ea typeface="Segoe UI" pitchFamily="34" charset="-122"/>
                 <a:cs typeface="Segoe UI" pitchFamily="34" charset="-120"/>
               </a:rPr>
-              <a:t>Settle</a:t>
+              <a:t>Payout release</a:t>
             </a:r>
             <a:endParaRPr lang="en-US" sz="1200" dirty="0"/>
           </a:p>
@@ -7002,7 +7046,7 @@
                 <a:ea typeface="Segoe UI" pitchFamily="34" charset="-122"/>
                 <a:cs typeface="Segoe UI" pitchFamily="34" charset="-120"/>
               </a:rPr>
-              <a:t>Doctor's prescription triggers payout</a:t>
+              <a:t>Prescription unlocks doctor balance</a:t>
             </a:r>
             <a:endParaRPr lang="en-US" sz="900" dirty="0"/>
           </a:p>
@@ -7058,7 +7102,7 @@
               <a:buNone/>
             </a:pPr>
             <a:r>
-              <a:rPr lang="en-US" sz="2800" b="1" dirty="0">
+              <a:rPr lang="en-US" sz="2600" b="1" dirty="0">
                 <a:solidFill>
                   <a:srgbClr val="2563EB"/>
                 </a:solidFill>
@@ -7066,120 +7110,22 @@
                 <a:ea typeface="Segoe UI" pitchFamily="34" charset="-122"/>
                 <a:cs typeface="Segoe UI" pitchFamily="34" charset="-120"/>
               </a:rPr>
-              <a:t>Gateway Directory Design</a:t>
-            </a:r>
-            <a:endParaRPr lang="en-US" sz="2800" dirty="0"/>
-          </a:p>
-        </p:txBody>
-      </p:sp>
-      <p:sp>
-        <p:nvSpPr>
-          <p:cNvPr id="3" name="Text 1"/>
-          <p:cNvSpPr/>
-          <p:nvPr/>
-        </p:nvSpPr>
-        <p:spPr>
-          <a:xfrm>
-            <a:off x="731520" y="1005840"/>
-            <a:ext cx="7772400" cy="365760"/>
-          </a:xfrm>
-          <a:prstGeom prst="rect">
-            <a:avLst/>
-          </a:prstGeom>
-          <a:noFill/>
-          <a:ln/>
-        </p:spPr>
-        <p:txBody>
-          <a:bodyPr wrap="square" rtlCol="0" anchor="ctr"/>
-          <a:lstStyle/>
-          <a:p>
-            <a:pPr indent="0" marL="0">
-              <a:buNone/>
-            </a:pPr>
-            <a:r>
-              <a:rPr lang="en-US" sz="1300" dirty="0">
-                <a:solidFill>
-                  <a:srgbClr val="64748B"/>
-                </a:solidFill>
-                <a:latin typeface="Segoe UI" pitchFamily="34" charset="0"/>
-                <a:ea typeface="Segoe UI" pitchFamily="34" charset="-122"/>
-                <a:cs typeface="Segoe UI" pitchFamily="34" charset="-120"/>
-              </a:rPr>
-              <a:t>Repository Pattern separating route controllers, business logic, and database operations:</a:t>
-            </a:r>
-            <a:endParaRPr lang="en-US" sz="1300" dirty="0"/>
-          </a:p>
-        </p:txBody>
-      </p:sp>
-      <p:sp>
-        <p:nvSpPr>
-          <p:cNvPr id="4" name="Shape 2"/>
-          <p:cNvSpPr/>
-          <p:nvPr/>
-        </p:nvSpPr>
-        <p:spPr>
-          <a:xfrm>
-            <a:off x="731520" y="1463040"/>
-            <a:ext cx="1828800" cy="640080"/>
-          </a:xfrm>
-          <a:prstGeom prst="rect">
-            <a:avLst/>
-          </a:prstGeom>
-          <a:solidFill>
-            <a:srgbClr val="2563EB"/>
-          </a:solidFill>
-          <a:ln/>
-        </p:spPr>
-      </p:sp>
-      <p:sp>
-        <p:nvSpPr>
-          <p:cNvPr id="5" name="Text 3"/>
-          <p:cNvSpPr/>
-          <p:nvPr/>
-        </p:nvSpPr>
-        <p:spPr>
-          <a:xfrm>
-            <a:off x="731520" y="1600200"/>
-            <a:ext cx="1828800" cy="365760"/>
-          </a:xfrm>
-          <a:prstGeom prst="rect">
-            <a:avLst/>
-          </a:prstGeom>
-          <a:noFill/>
-          <a:ln/>
-        </p:spPr>
-        <p:txBody>
-          <a:bodyPr wrap="square" rtlCol="0" anchor="ctr"/>
-          <a:lstStyle/>
-          <a:p>
-            <a:pPr algn="ctr" indent="0" marL="0">
-              <a:buNone/>
-            </a:pPr>
-            <a:r>
-              <a:rPr lang="en-US" sz="1100" b="1" dirty="0">
-                <a:solidFill>
-                  <a:srgbClr val="FFFFFF"/>
-                </a:solidFill>
-                <a:latin typeface="Segoe UI" pitchFamily="34" charset="0"/>
-                <a:ea typeface="Segoe UI" pitchFamily="34" charset="-122"/>
-                <a:cs typeface="Segoe UI" pitchFamily="34" charset="-120"/>
-              </a:rPr>
-              <a:t>Routes Layer</a:t>
-            </a:r>
-            <a:endParaRPr lang="en-US" sz="1100" dirty="0"/>
-          </a:p>
-        </p:txBody>
-      </p:sp>
-      <p:sp>
-        <p:nvSpPr>
-          <p:cNvPr id="6" name="Shape 4"/>
-          <p:cNvSpPr/>
-          <p:nvPr/>
-        </p:nvSpPr>
-        <p:spPr>
-          <a:xfrm>
-            <a:off x="2651760" y="1463040"/>
-            <a:ext cx="5760720" cy="640080"/>
+              <a:t>Feature Matrix Modules</a:t>
+            </a:r>
+            <a:endParaRPr lang="en-US" sz="2600" dirty="0"/>
+          </a:p>
+        </p:txBody>
+      </p:sp>
+      <p:sp>
+        <p:nvSpPr>
+          <p:cNvPr id="3" name="Shape 1"/>
+          <p:cNvSpPr/>
+          <p:nvPr/>
+        </p:nvSpPr>
+        <p:spPr>
+          <a:xfrm>
+            <a:off x="731520" y="1280160"/>
+            <a:ext cx="2423160" cy="3200400"/>
           </a:xfrm>
           <a:prstGeom prst="rect">
             <a:avLst/>
@@ -7197,14 +7143,14 @@
       </p:sp>
       <p:sp>
         <p:nvSpPr>
-          <p:cNvPr id="7" name="Text 5"/>
-          <p:cNvSpPr/>
-          <p:nvPr/>
-        </p:nvSpPr>
-        <p:spPr>
-          <a:xfrm>
-            <a:off x="2834640" y="1554480"/>
-            <a:ext cx="5486400" cy="457200"/>
+          <p:cNvPr id="4" name="Text 2"/>
+          <p:cNvSpPr/>
+          <p:nvPr/>
+        </p:nvSpPr>
+        <p:spPr>
+          <a:xfrm>
+            <a:off x="868680" y="1463040"/>
+            <a:ext cx="2148840" cy="365760"/>
           </a:xfrm>
           <a:prstGeom prst="rect">
             <a:avLst/>
@@ -7220,7 +7166,49 @@
               <a:buNone/>
             </a:pPr>
             <a:r>
-              <a:rPr lang="en-US" sz="1000" dirty="0">
+              <a:rPr lang="en-US" sz="1400" b="1" dirty="0">
+                <a:solidFill>
+                  <a:srgbClr val="2563EB"/>
+                </a:solidFill>
+                <a:latin typeface="Segoe UI" pitchFamily="34" charset="0"/>
+                <a:ea typeface="Segoe UI" pitchFamily="34" charset="-122"/>
+                <a:cs typeface="Segoe UI" pitchFamily="34" charset="-120"/>
+              </a:rPr>
+              <a:t>Patient Portal</a:t>
+            </a:r>
+            <a:endParaRPr lang="en-US" sz="1400" dirty="0"/>
+          </a:p>
+        </p:txBody>
+      </p:sp>
+      <p:sp>
+        <p:nvSpPr>
+          <p:cNvPr id="5" name="Text 3"/>
+          <p:cNvSpPr/>
+          <p:nvPr/>
+        </p:nvSpPr>
+        <p:spPr>
+          <a:xfrm>
+            <a:off x="868680" y="1920240"/>
+            <a:ext cx="2148840" cy="2377440"/>
+          </a:xfrm>
+          <a:prstGeom prst="rect">
+            <a:avLst/>
+          </a:prstGeom>
+          <a:noFill/>
+          <a:ln/>
+        </p:spPr>
+        <p:txBody>
+          <a:bodyPr wrap="square" rtlCol="0" anchor="ctr"/>
+          <a:lstStyle/>
+          <a:p>
+            <a:pPr indent="0" marL="0">
+              <a:lnSpc>
+                <a:spcPts val="600"/>
+              </a:lnSpc>
+              <a:buNone/>
+            </a:pPr>
+            <a:r>
+              <a:rPr lang="en-US" sz="1100" dirty="0">
                 <a:solidFill>
                   <a:srgbClr val="1E293B"/>
                 </a:solidFill>
@@ -7228,16 +7216,19 @@
                 <a:ea typeface="Segoe UI" pitchFamily="34" charset="-122"/>
                 <a:cs typeface="Segoe UI" pitchFamily="34" charset="-120"/>
               </a:rPr>
-              <a:t>publicRoutes.js</a:t>
-            </a:r>
-            <a:endParaRPr lang="en-US" sz="1000" dirty="0"/>
+              <a:t>• Scan medical reports</a:t>
+            </a:r>
+            <a:endParaRPr lang="en-US" sz="1100" dirty="0"/>
           </a:p>
           <a:p>
             <a:pPr indent="0" marL="0">
-              <a:buNone/>
-            </a:pPr>
-            <a:r>
-              <a:rPr lang="en-US" sz="1000" dirty="0">
+              <a:lnSpc>
+                <a:spcPts val="600"/>
+              </a:lnSpc>
+              <a:buNone/>
+            </a:pPr>
+            <a:r>
+              <a:rPr lang="en-US" sz="1100" dirty="0">
                 <a:solidFill>
                   <a:srgbClr val="1E293B"/>
                 </a:solidFill>
@@ -7245,81 +7236,82 @@
                 <a:ea typeface="Segoe UI" pitchFamily="34" charset="-122"/>
                 <a:cs typeface="Segoe UI" pitchFamily="34" charset="-120"/>
               </a:rPr>
-              <a:t>appointmentRoutes.js  |  Maps URL endpoints to controller methods, applying security/cors middlewares.</a:t>
-            </a:r>
-            <a:endParaRPr lang="en-US" sz="1000" dirty="0"/>
-          </a:p>
-        </p:txBody>
-      </p:sp>
-      <p:sp>
-        <p:nvSpPr>
-          <p:cNvPr id="8" name="Shape 6"/>
-          <p:cNvSpPr/>
-          <p:nvPr/>
-        </p:nvSpPr>
-        <p:spPr>
-          <a:xfrm>
-            <a:off x="731520" y="2240280"/>
-            <a:ext cx="1828800" cy="640080"/>
-          </a:xfrm>
-          <a:prstGeom prst="rect">
-            <a:avLst/>
-          </a:prstGeom>
-          <a:solidFill>
-            <a:srgbClr val="2563EB"/>
-          </a:solidFill>
-          <a:ln/>
-        </p:spPr>
-      </p:sp>
-      <p:sp>
-        <p:nvSpPr>
-          <p:cNvPr id="9" name="Text 7"/>
-          <p:cNvSpPr/>
-          <p:nvPr/>
-        </p:nvSpPr>
-        <p:spPr>
-          <a:xfrm>
-            <a:off x="731520" y="2377440"/>
-            <a:ext cx="1828800" cy="365760"/>
-          </a:xfrm>
-          <a:prstGeom prst="rect">
-            <a:avLst/>
-          </a:prstGeom>
-          <a:noFill/>
-          <a:ln/>
-        </p:spPr>
-        <p:txBody>
-          <a:bodyPr wrap="square" rtlCol="0" anchor="ctr"/>
-          <a:lstStyle/>
-          <a:p>
-            <a:pPr algn="ctr" indent="0" marL="0">
-              <a:buNone/>
-            </a:pPr>
-            <a:r>
-              <a:rPr lang="en-US" sz="1100" b="1" dirty="0">
-                <a:solidFill>
-                  <a:srgbClr val="FFFFFF"/>
-                </a:solidFill>
-                <a:latin typeface="Segoe UI" pitchFamily="34" charset="0"/>
-                <a:ea typeface="Segoe UI" pitchFamily="34" charset="-122"/>
-                <a:cs typeface="Segoe UI" pitchFamily="34" charset="-120"/>
-              </a:rPr>
-              <a:t>Controllers</a:t>
+              <a:t>• Search &amp; filter doctors</a:t>
             </a:r>
             <a:endParaRPr lang="en-US" sz="1100" dirty="0"/>
           </a:p>
-        </p:txBody>
-      </p:sp>
-      <p:sp>
-        <p:nvSpPr>
-          <p:cNvPr id="10" name="Shape 8"/>
-          <p:cNvSpPr/>
-          <p:nvPr/>
-        </p:nvSpPr>
-        <p:spPr>
-          <a:xfrm>
-            <a:off x="2651760" y="2240280"/>
-            <a:ext cx="5760720" cy="640080"/>
+          <a:p>
+            <a:pPr indent="0" marL="0">
+              <a:lnSpc>
+                <a:spcPts val="600"/>
+              </a:lnSpc>
+              <a:buNone/>
+            </a:pPr>
+            <a:r>
+              <a:rPr lang="en-US" sz="1100" dirty="0">
+                <a:solidFill>
+                  <a:srgbClr val="1E293B"/>
+                </a:solidFill>
+                <a:latin typeface="Segoe UI" pitchFamily="34" charset="0"/>
+                <a:ea typeface="Segoe UI" pitchFamily="34" charset="-122"/>
+                <a:cs typeface="Segoe UI" pitchFamily="34" charset="-120"/>
+              </a:rPr>
+              <a:t>• Book slots with locking</a:t>
+            </a:r>
+            <a:endParaRPr lang="en-US" sz="1100" dirty="0"/>
+          </a:p>
+          <a:p>
+            <a:pPr indent="0" marL="0">
+              <a:lnSpc>
+                <a:spcPts val="600"/>
+              </a:lnSpc>
+              <a:buNone/>
+            </a:pPr>
+            <a:r>
+              <a:rPr lang="en-US" sz="1100" dirty="0">
+                <a:solidFill>
+                  <a:srgbClr val="1E293B"/>
+                </a:solidFill>
+                <a:latin typeface="Segoe UI" pitchFamily="34" charset="0"/>
+                <a:ea typeface="Segoe UI" pitchFamily="34" charset="-122"/>
+                <a:cs typeface="Segoe UI" pitchFamily="34" charset="-120"/>
+              </a:rPr>
+              <a:t>• Order medicines</a:t>
+            </a:r>
+            <a:endParaRPr lang="en-US" sz="1100" dirty="0"/>
+          </a:p>
+          <a:p>
+            <a:pPr indent="0" marL="0">
+              <a:lnSpc>
+                <a:spcPts val="600"/>
+              </a:lnSpc>
+              <a:buNone/>
+            </a:pPr>
+            <a:r>
+              <a:rPr lang="en-US" sz="1100" dirty="0">
+                <a:solidFill>
+                  <a:srgbClr val="1E293B"/>
+                </a:solidFill>
+                <a:latin typeface="Segoe UI" pitchFamily="34" charset="0"/>
+                <a:ea typeface="Segoe UI" pitchFamily="34" charset="-122"/>
+                <a:cs typeface="Segoe UI" pitchFamily="34" charset="-120"/>
+              </a:rPr>
+              <a:t>• Live Doctor Chat</a:t>
+            </a:r>
+            <a:endParaRPr lang="en-US" sz="1100" dirty="0"/>
+          </a:p>
+        </p:txBody>
+      </p:sp>
+      <p:sp>
+        <p:nvSpPr>
+          <p:cNvPr id="6" name="Shape 4"/>
+          <p:cNvSpPr/>
+          <p:nvPr/>
+        </p:nvSpPr>
+        <p:spPr>
+          <a:xfrm>
+            <a:off x="3337560" y="1280160"/>
+            <a:ext cx="2423160" cy="3200400"/>
           </a:xfrm>
           <a:prstGeom prst="rect">
             <a:avLst/>
@@ -7337,14 +7329,14 @@
       </p:sp>
       <p:sp>
         <p:nvSpPr>
-          <p:cNvPr id="11" name="Text 9"/>
-          <p:cNvSpPr/>
-          <p:nvPr/>
-        </p:nvSpPr>
-        <p:spPr>
-          <a:xfrm>
-            <a:off x="2834640" y="2331720"/>
-            <a:ext cx="5486400" cy="457200"/>
+          <p:cNvPr id="7" name="Text 5"/>
+          <p:cNvSpPr/>
+          <p:nvPr/>
+        </p:nvSpPr>
+        <p:spPr>
+          <a:xfrm>
+            <a:off x="3474720" y="1463040"/>
+            <a:ext cx="2148840" cy="365760"/>
           </a:xfrm>
           <a:prstGeom prst="rect">
             <a:avLst/>
@@ -7360,7 +7352,49 @@
               <a:buNone/>
             </a:pPr>
             <a:r>
-              <a:rPr lang="en-US" sz="1000" dirty="0">
+              <a:rPr lang="en-US" sz="1400" b="1" dirty="0">
+                <a:solidFill>
+                  <a:srgbClr val="2563EB"/>
+                </a:solidFill>
+                <a:latin typeface="Segoe UI" pitchFamily="34" charset="0"/>
+                <a:ea typeface="Segoe UI" pitchFamily="34" charset="-122"/>
+                <a:cs typeface="Segoe UI" pitchFamily="34" charset="-120"/>
+              </a:rPr>
+              <a:t>Doctor Portal</a:t>
+            </a:r>
+            <a:endParaRPr lang="en-US" sz="1400" dirty="0"/>
+          </a:p>
+        </p:txBody>
+      </p:sp>
+      <p:sp>
+        <p:nvSpPr>
+          <p:cNvPr id="8" name="Text 6"/>
+          <p:cNvSpPr/>
+          <p:nvPr/>
+        </p:nvSpPr>
+        <p:spPr>
+          <a:xfrm>
+            <a:off x="3474720" y="1920240"/>
+            <a:ext cx="2148840" cy="2377440"/>
+          </a:xfrm>
+          <a:prstGeom prst="rect">
+            <a:avLst/>
+          </a:prstGeom>
+          <a:noFill/>
+          <a:ln/>
+        </p:spPr>
+        <p:txBody>
+          <a:bodyPr wrap="square" rtlCol="0" anchor="ctr"/>
+          <a:lstStyle/>
+          <a:p>
+            <a:pPr indent="0" marL="0">
+              <a:lnSpc>
+                <a:spcPts val="600"/>
+              </a:lnSpc>
+              <a:buNone/>
+            </a:pPr>
+            <a:r>
+              <a:rPr lang="en-US" sz="1100" dirty="0">
                 <a:solidFill>
                   <a:srgbClr val="1E293B"/>
                 </a:solidFill>
@@ -7368,16 +7402,19 @@
                 <a:ea typeface="Segoe UI" pitchFamily="34" charset="-122"/>
                 <a:cs typeface="Segoe UI" pitchFamily="34" charset="-120"/>
               </a:rPr>
-              <a:t>authController.js</a:t>
-            </a:r>
-            <a:endParaRPr lang="en-US" sz="1000" dirty="0"/>
+              <a:t>• Add/Delete open slots</a:t>
+            </a:r>
+            <a:endParaRPr lang="en-US" sz="1100" dirty="0"/>
           </a:p>
           <a:p>
             <a:pPr indent="0" marL="0">
-              <a:buNone/>
-            </a:pPr>
-            <a:r>
-              <a:rPr lang="en-US" sz="1000" dirty="0">
+              <a:lnSpc>
+                <a:spcPts val="600"/>
+              </a:lnSpc>
+              <a:buNone/>
+            </a:pPr>
+            <a:r>
+              <a:rPr lang="en-US" sz="1100" dirty="0">
                 <a:solidFill>
                   <a:srgbClr val="1E293B"/>
                 </a:solidFill>
@@ -7385,81 +7422,82 @@
                 <a:ea typeface="Segoe UI" pitchFamily="34" charset="-122"/>
                 <a:cs typeface="Segoe UI" pitchFamily="34" charset="-120"/>
               </a:rPr>
-              <a:t>appointmentController.js  |  Extracts request payloads, verifies inputs, and sends structured JSON API responses.</a:t>
-            </a:r>
-            <a:endParaRPr lang="en-US" sz="1000" dirty="0"/>
-          </a:p>
-        </p:txBody>
-      </p:sp>
-      <p:sp>
-        <p:nvSpPr>
-          <p:cNvPr id="12" name="Shape 10"/>
-          <p:cNvSpPr/>
-          <p:nvPr/>
-        </p:nvSpPr>
-        <p:spPr>
-          <a:xfrm>
-            <a:off x="731520" y="3017520"/>
-            <a:ext cx="1828800" cy="640080"/>
-          </a:xfrm>
-          <a:prstGeom prst="rect">
-            <a:avLst/>
-          </a:prstGeom>
-          <a:solidFill>
-            <a:srgbClr val="2563EB"/>
-          </a:solidFill>
-          <a:ln/>
-        </p:spPr>
-      </p:sp>
-      <p:sp>
-        <p:nvSpPr>
-          <p:cNvPr id="13" name="Text 11"/>
-          <p:cNvSpPr/>
-          <p:nvPr/>
-        </p:nvSpPr>
-        <p:spPr>
-          <a:xfrm>
-            <a:off x="731520" y="3154680"/>
-            <a:ext cx="1828800" cy="365760"/>
-          </a:xfrm>
-          <a:prstGeom prst="rect">
-            <a:avLst/>
-          </a:prstGeom>
-          <a:noFill/>
-          <a:ln/>
-        </p:spPr>
-        <p:txBody>
-          <a:bodyPr wrap="square" rtlCol="0" anchor="ctr"/>
-          <a:lstStyle/>
-          <a:p>
-            <a:pPr algn="ctr" indent="0" marL="0">
-              <a:buNone/>
-            </a:pPr>
-            <a:r>
-              <a:rPr lang="en-US" sz="1100" b="1" dirty="0">
-                <a:solidFill>
-                  <a:srgbClr val="FFFFFF"/>
-                </a:solidFill>
-                <a:latin typeface="Segoe UI" pitchFamily="34" charset="0"/>
-                <a:ea typeface="Segoe UI" pitchFamily="34" charset="-122"/>
-                <a:cs typeface="Segoe UI" pitchFamily="34" charset="-120"/>
-              </a:rPr>
-              <a:t>Services Layer</a:t>
+              <a:t>• Review booking cards</a:t>
             </a:r>
             <a:endParaRPr lang="en-US" sz="1100" dirty="0"/>
           </a:p>
-        </p:txBody>
-      </p:sp>
-      <p:sp>
-        <p:nvSpPr>
-          <p:cNvPr id="14" name="Shape 12"/>
-          <p:cNvSpPr/>
-          <p:nvPr/>
-        </p:nvSpPr>
-        <p:spPr>
-          <a:xfrm>
-            <a:off x="2651760" y="3017520"/>
-            <a:ext cx="5760720" cy="640080"/>
+          <a:p>
+            <a:pPr indent="0" marL="0">
+              <a:lnSpc>
+                <a:spcPts val="600"/>
+              </a:lnSpc>
+              <a:buNone/>
+            </a:pPr>
+            <a:r>
+              <a:rPr lang="en-US" sz="1100" dirty="0">
+                <a:solidFill>
+                  <a:srgbClr val="1E293B"/>
+                </a:solidFill>
+                <a:latin typeface="Segoe UI" pitchFamily="34" charset="0"/>
+                <a:ea typeface="Segoe UI" pitchFamily="34" charset="-122"/>
+                <a:cs typeface="Segoe UI" pitchFamily="34" charset="-120"/>
+              </a:rPr>
+              <a:t>• Accept or reject requests</a:t>
+            </a:r>
+            <a:endParaRPr lang="en-US" sz="1100" dirty="0"/>
+          </a:p>
+          <a:p>
+            <a:pPr indent="0" marL="0">
+              <a:lnSpc>
+                <a:spcPts val="600"/>
+              </a:lnSpc>
+              <a:buNone/>
+            </a:pPr>
+            <a:r>
+              <a:rPr lang="en-US" sz="1100" dirty="0">
+                <a:solidFill>
+                  <a:srgbClr val="1E293B"/>
+                </a:solidFill>
+                <a:latin typeface="Segoe UI" pitchFamily="34" charset="0"/>
+                <a:ea typeface="Segoe UI" pitchFamily="34" charset="-122"/>
+                <a:cs typeface="Segoe UI" pitchFamily="34" charset="-120"/>
+              </a:rPr>
+              <a:t>• Prescribe medicines</a:t>
+            </a:r>
+            <a:endParaRPr lang="en-US" sz="1100" dirty="0"/>
+          </a:p>
+          <a:p>
+            <a:pPr indent="0" marL="0">
+              <a:lnSpc>
+                <a:spcPts val="600"/>
+              </a:lnSpc>
+              <a:buNone/>
+            </a:pPr>
+            <a:r>
+              <a:rPr lang="en-US" sz="1100" dirty="0">
+                <a:solidFill>
+                  <a:srgbClr val="1E293B"/>
+                </a:solidFill>
+                <a:latin typeface="Segoe UI" pitchFamily="34" charset="0"/>
+                <a:ea typeface="Segoe UI" pitchFamily="34" charset="-122"/>
+                <a:cs typeface="Segoe UI" pitchFamily="34" charset="-120"/>
+              </a:rPr>
+              <a:t>• Check earnings wallet</a:t>
+            </a:r>
+            <a:endParaRPr lang="en-US" sz="1100" dirty="0"/>
+          </a:p>
+        </p:txBody>
+      </p:sp>
+      <p:sp>
+        <p:nvSpPr>
+          <p:cNvPr id="9" name="Shape 7"/>
+          <p:cNvSpPr/>
+          <p:nvPr/>
+        </p:nvSpPr>
+        <p:spPr>
+          <a:xfrm>
+            <a:off x="5943600" y="1280160"/>
+            <a:ext cx="2423160" cy="3200400"/>
           </a:xfrm>
           <a:prstGeom prst="rect">
             <a:avLst/>
@@ -7477,14 +7515,14 @@
       </p:sp>
       <p:sp>
         <p:nvSpPr>
-          <p:cNvPr id="15" name="Text 13"/>
-          <p:cNvSpPr/>
-          <p:nvPr/>
-        </p:nvSpPr>
-        <p:spPr>
-          <a:xfrm>
-            <a:off x="2834640" y="3108960"/>
-            <a:ext cx="5486400" cy="457200"/>
+          <p:cNvPr id="10" name="Text 8"/>
+          <p:cNvSpPr/>
+          <p:nvPr/>
+        </p:nvSpPr>
+        <p:spPr>
+          <a:xfrm>
+            <a:off x="6080760" y="1463040"/>
+            <a:ext cx="2148840" cy="365760"/>
           </a:xfrm>
           <a:prstGeom prst="rect">
             <a:avLst/>
@@ -7500,7 +7538,49 @@
               <a:buNone/>
             </a:pPr>
             <a:r>
-              <a:rPr lang="en-US" sz="1000" dirty="0">
+              <a:rPr lang="en-US" sz="1400" b="1" dirty="0">
+                <a:solidFill>
+                  <a:srgbClr val="2563EB"/>
+                </a:solidFill>
+                <a:latin typeface="Segoe UI" pitchFamily="34" charset="0"/>
+                <a:ea typeface="Segoe UI" pitchFamily="34" charset="-122"/>
+                <a:cs typeface="Segoe UI" pitchFamily="34" charset="-120"/>
+              </a:rPr>
+              <a:t>Merchant / Admin</a:t>
+            </a:r>
+            <a:endParaRPr lang="en-US" sz="1400" dirty="0"/>
+          </a:p>
+        </p:txBody>
+      </p:sp>
+      <p:sp>
+        <p:nvSpPr>
+          <p:cNvPr id="11" name="Text 9"/>
+          <p:cNvSpPr/>
+          <p:nvPr/>
+        </p:nvSpPr>
+        <p:spPr>
+          <a:xfrm>
+            <a:off x="6080760" y="1920240"/>
+            <a:ext cx="2148840" cy="2377440"/>
+          </a:xfrm>
+          <a:prstGeom prst="rect">
+            <a:avLst/>
+          </a:prstGeom>
+          <a:noFill/>
+          <a:ln/>
+        </p:spPr>
+        <p:txBody>
+          <a:bodyPr wrap="square" rtlCol="0" anchor="ctr"/>
+          <a:lstStyle/>
+          <a:p>
+            <a:pPr indent="0" marL="0">
+              <a:lnSpc>
+                <a:spcPts val="600"/>
+              </a:lnSpc>
+              <a:buNone/>
+            </a:pPr>
+            <a:r>
+              <a:rPr lang="en-US" sz="1100" dirty="0">
                 <a:solidFill>
                   <a:srgbClr val="1E293B"/>
                 </a:solidFill>
@@ -7508,16 +7588,19 @@
                 <a:ea typeface="Segoe UI" pitchFamily="34" charset="-122"/>
                 <a:cs typeface="Segoe UI" pitchFamily="34" charset="-120"/>
               </a:rPr>
-              <a:t>userService.js</a:t>
-            </a:r>
-            <a:endParaRPr lang="en-US" sz="1000" dirty="0"/>
+              <a:t>• Fulfill patient drug orders</a:t>
+            </a:r>
+            <a:endParaRPr lang="en-US" sz="1100" dirty="0"/>
           </a:p>
           <a:p>
             <a:pPr indent="0" marL="0">
-              <a:buNone/>
-            </a:pPr>
-            <a:r>
-              <a:rPr lang="en-US" sz="1000" dirty="0">
+              <a:lnSpc>
+                <a:spcPts val="600"/>
+              </a:lnSpc>
+              <a:buNone/>
+            </a:pPr>
+            <a:r>
+              <a:rPr lang="en-US" sz="1100" dirty="0">
                 <a:solidFill>
                   <a:srgbClr val="1E293B"/>
                 </a:solidFill>
@@ -7525,16 +7608,19 @@
                 <a:ea typeface="Segoe UI" pitchFamily="34" charset="-122"/>
                 <a:cs typeface="Segoe UI" pitchFamily="34" charset="-120"/>
               </a:rPr>
-              <a:t>emailService.js</a:t>
-            </a:r>
-            <a:endParaRPr lang="en-US" sz="1000" dirty="0"/>
+              <a:t>• Manage inventory listings</a:t>
+            </a:r>
+            <a:endParaRPr lang="en-US" sz="1100" dirty="0"/>
           </a:p>
           <a:p>
             <a:pPr indent="0" marL="0">
-              <a:buNone/>
-            </a:pPr>
-            <a:r>
-              <a:rPr lang="en-US" sz="1000" dirty="0">
+              <a:lnSpc>
+                <a:spcPts val="600"/>
+              </a:lnSpc>
+              <a:buNone/>
+            </a:pPr>
+            <a:r>
+              <a:rPr lang="en-US" sz="1100" dirty="0">
                 <a:solidFill>
                   <a:srgbClr val="1E293B"/>
                 </a:solidFill>
@@ -7542,122 +7628,19 @@
                 <a:ea typeface="Segoe UI" pitchFamily="34" charset="-122"/>
                 <a:cs typeface="Segoe UI" pitchFamily="34" charset="-120"/>
               </a:rPr>
-              <a:t>otpService.js  |  Handles core business validation (e.g. hashing passwords, generating JWTs, in-memory OTP).</a:t>
-            </a:r>
-            <a:endParaRPr lang="en-US" sz="1000" dirty="0"/>
-          </a:p>
-        </p:txBody>
-      </p:sp>
-      <p:sp>
-        <p:nvSpPr>
-          <p:cNvPr id="16" name="Shape 14"/>
-          <p:cNvSpPr/>
-          <p:nvPr/>
-        </p:nvSpPr>
-        <p:spPr>
-          <a:xfrm>
-            <a:off x="731520" y="3794760"/>
-            <a:ext cx="1828800" cy="640080"/>
-          </a:xfrm>
-          <a:prstGeom prst="rect">
-            <a:avLst/>
-          </a:prstGeom>
-          <a:solidFill>
-            <a:srgbClr val="2563EB"/>
-          </a:solidFill>
-          <a:ln/>
-        </p:spPr>
-      </p:sp>
-      <p:sp>
-        <p:nvSpPr>
-          <p:cNvPr id="17" name="Text 15"/>
-          <p:cNvSpPr/>
-          <p:nvPr/>
-        </p:nvSpPr>
-        <p:spPr>
-          <a:xfrm>
-            <a:off x="731520" y="3931920"/>
-            <a:ext cx="1828800" cy="365760"/>
-          </a:xfrm>
-          <a:prstGeom prst="rect">
-            <a:avLst/>
-          </a:prstGeom>
-          <a:noFill/>
-          <a:ln/>
-        </p:spPr>
-        <p:txBody>
-          <a:bodyPr wrap="square" rtlCol="0" anchor="ctr"/>
-          <a:lstStyle/>
-          <a:p>
-            <a:pPr algn="ctr" indent="0" marL="0">
-              <a:buNone/>
-            </a:pPr>
-            <a:r>
-              <a:rPr lang="en-US" sz="1100" b="1" dirty="0">
-                <a:solidFill>
-                  <a:srgbClr val="FFFFFF"/>
-                </a:solidFill>
-                <a:latin typeface="Segoe UI" pitchFamily="34" charset="0"/>
-                <a:ea typeface="Segoe UI" pitchFamily="34" charset="-122"/>
-                <a:cs typeface="Segoe UI" pitchFamily="34" charset="-120"/>
-              </a:rPr>
-              <a:t>Repositories</a:t>
+              <a:t>• Audit balances &amp; commission</a:t>
             </a:r>
             <a:endParaRPr lang="en-US" sz="1100" dirty="0"/>
           </a:p>
-        </p:txBody>
-      </p:sp>
-      <p:sp>
-        <p:nvSpPr>
-          <p:cNvPr id="18" name="Shape 16"/>
-          <p:cNvSpPr/>
-          <p:nvPr/>
-        </p:nvSpPr>
-        <p:spPr>
-          <a:xfrm>
-            <a:off x="2651760" y="3794760"/>
-            <a:ext cx="5760720" cy="640080"/>
-          </a:xfrm>
-          <a:prstGeom prst="rect">
-            <a:avLst/>
-          </a:prstGeom>
-          <a:solidFill>
-            <a:srgbClr val="F8FAFC"/>
-          </a:solidFill>
-          <a:ln w="12700">
-            <a:solidFill>
-              <a:srgbClr val="E2E8F0"/>
-            </a:solidFill>
-            <a:prstDash val="solid"/>
-          </a:ln>
-        </p:spPr>
-      </p:sp>
-      <p:sp>
-        <p:nvSpPr>
-          <p:cNvPr id="19" name="Text 17"/>
-          <p:cNvSpPr/>
-          <p:nvPr/>
-        </p:nvSpPr>
-        <p:spPr>
-          <a:xfrm>
-            <a:off x="2834640" y="3886200"/>
-            <a:ext cx="5486400" cy="457200"/>
-          </a:xfrm>
-          <a:prstGeom prst="rect">
-            <a:avLst/>
-          </a:prstGeom>
-          <a:noFill/>
-          <a:ln/>
-        </p:spPr>
-        <p:txBody>
-          <a:bodyPr wrap="square" rtlCol="0" anchor="ctr"/>
-          <a:lstStyle/>
           <a:p>
             <a:pPr indent="0" marL="0">
-              <a:buNone/>
-            </a:pPr>
-            <a:r>
-              <a:rPr lang="en-US" sz="1000" dirty="0">
+              <a:lnSpc>
+                <a:spcPts val="600"/>
+              </a:lnSpc>
+              <a:buNone/>
+            </a:pPr>
+            <a:r>
+              <a:rPr lang="en-US" sz="1100" dirty="0">
                 <a:solidFill>
                   <a:srgbClr val="1E293B"/>
                 </a:solidFill>
@@ -7665,26 +7648,9 @@
                 <a:ea typeface="Segoe UI" pitchFamily="34" charset="-122"/>
                 <a:cs typeface="Segoe UI" pitchFamily="34" charset="-120"/>
               </a:rPr>
-              <a:t>doctorRepository.js</a:t>
-            </a:r>
-            <a:endParaRPr lang="en-US" sz="1000" dirty="0"/>
-          </a:p>
-          <a:p>
-            <a:pPr indent="0" marL="0">
-              <a:buNone/>
-            </a:pPr>
-            <a:r>
-              <a:rPr lang="en-US" sz="1000" dirty="0">
-                <a:solidFill>
-                  <a:srgbClr val="1E293B"/>
-                </a:solidFill>
-                <a:latin typeface="Segoe UI" pitchFamily="34" charset="0"/>
-                <a:ea typeface="Segoe UI" pitchFamily="34" charset="-122"/>
-                <a:cs typeface="Segoe UI" pitchFamily="34" charset="-120"/>
-              </a:rPr>
-              <a:t>appointmentRepository.js  |  Contains all database queries. Separating SQL makes the app testable and database-agnostic.</a:t>
-            </a:r>
-            <a:endParaRPr lang="en-US" sz="1000" dirty="0"/>
+              <a:t>• Approve newly registered practitioners</a:t>
+            </a:r>
+            <a:endParaRPr lang="en-US" sz="1100" dirty="0"/>
           </a:p>
         </p:txBody>
       </p:sp>
@@ -7738,7 +7704,7 @@
               <a:buNone/>
             </a:pPr>
             <a:r>
-              <a:rPr lang="en-US" sz="2800" b="1" dirty="0">
+              <a:rPr lang="en-US" sz="2600" b="1" dirty="0">
                 <a:solidFill>
                   <a:srgbClr val="2563EB"/>
                 </a:solidFill>
@@ -7746,9 +7712,9 @@
                 <a:ea typeface="Segoe UI" pitchFamily="34" charset="-122"/>
                 <a:cs typeface="Segoe UI" pitchFamily="34" charset="-120"/>
               </a:rPr>
-              <a:t>Authentication &amp; Security Blueprint</a:t>
-            </a:r>
-            <a:endParaRPr lang="en-US" sz="2800" dirty="0"/>
+              <a:t>Database Table Schemas</a:t>
+            </a:r>
+            <a:endParaRPr lang="en-US" sz="2600" dirty="0"/>
           </a:p>
         </p:txBody>
       </p:sp>
@@ -7760,8 +7726,8 @@
         </p:nvSpPr>
         <p:spPr>
           <a:xfrm>
-            <a:off x="731520" y="1280160"/>
-            <a:ext cx="7680960" cy="3108960"/>
+            <a:off x="731520" y="914400"/>
+            <a:ext cx="7772400" cy="365760"/>
           </a:xfrm>
           <a:prstGeom prst="rect">
             <a:avLst/>
@@ -7777,7 +7743,71 @@
               <a:buNone/>
             </a:pPr>
             <a:r>
-              <a:rPr lang="en-US" sz="1200" b="1" dirty="0">
+              <a:rPr lang="en-US" sz="1300" dirty="0">
+                <a:solidFill>
+                  <a:srgbClr val="64748B"/>
+                </a:solidFill>
+                <a:latin typeface="Segoe UI" pitchFamily="34" charset="0"/>
+                <a:ea typeface="Segoe UI" pitchFamily="34" charset="-122"/>
+                <a:cs typeface="Segoe UI" pitchFamily="34" charset="-120"/>
+              </a:rPr>
+              <a:t>Relational database schema enforcing reference integrity across system tables:</a:t>
+            </a:r>
+            <a:endParaRPr lang="en-US" sz="1300" dirty="0"/>
+          </a:p>
+        </p:txBody>
+      </p:sp>
+      <p:sp>
+        <p:nvSpPr>
+          <p:cNvPr id="4" name="Shape 2"/>
+          <p:cNvSpPr/>
+          <p:nvPr/>
+        </p:nvSpPr>
+        <p:spPr>
+          <a:xfrm>
+            <a:off x="731520" y="1371600"/>
+            <a:ext cx="1828800" cy="3017520"/>
+          </a:xfrm>
+          <a:prstGeom prst="rect">
+            <a:avLst/>
+          </a:prstGeom>
+          <a:solidFill>
+            <a:srgbClr val="F8FAFC"/>
+          </a:solidFill>
+          <a:ln w="12700">
+            <a:solidFill>
+              <a:srgbClr val="E2E8F0"/>
+            </a:solidFill>
+            <a:prstDash val="solid"/>
+          </a:ln>
+        </p:spPr>
+      </p:sp>
+      <p:sp>
+        <p:nvSpPr>
+          <p:cNvPr id="5" name="Text 3"/>
+          <p:cNvSpPr/>
+          <p:nvPr/>
+        </p:nvSpPr>
+        <p:spPr>
+          <a:xfrm>
+            <a:off x="822960" y="1554480"/>
+            <a:ext cx="1645920" cy="274320"/>
+          </a:xfrm>
+          <a:prstGeom prst="rect">
+            <a:avLst/>
+          </a:prstGeom>
+          <a:noFill/>
+          <a:ln/>
+        </p:spPr>
+        <p:txBody>
+          <a:bodyPr wrap="square" rtlCol="0" anchor="ctr"/>
+          <a:lstStyle/>
+          <a:p>
+            <a:pPr algn="ctr" indent="0" marL="0">
+              <a:buNone/>
+            </a:pPr>
+            <a:r>
+              <a:rPr lang="en-US" sz="1300" b="1" dirty="0">
                 <a:solidFill>
                   <a:srgbClr val="2563EB"/>
                 </a:solidFill>
@@ -7785,14 +7815,41 @@
                 <a:ea typeface="Segoe UI" pitchFamily="34" charset="-122"/>
                 <a:cs typeface="Segoe UI" pitchFamily="34" charset="-120"/>
               </a:rPr>
-              <a:t>• Cryptographic Salting:
-</a:t>
-            </a:r>
+              <a:t>users (Patients)</a:t>
+            </a:r>
+            <a:endParaRPr lang="en-US" sz="1300" dirty="0"/>
+          </a:p>
+        </p:txBody>
+      </p:sp>
+      <p:sp>
+        <p:nvSpPr>
+          <p:cNvPr id="6" name="Text 4"/>
+          <p:cNvSpPr/>
+          <p:nvPr/>
+        </p:nvSpPr>
+        <p:spPr>
+          <a:xfrm>
+            <a:off x="822960" y="1920240"/>
+            <a:ext cx="1645920" cy="2286000"/>
+          </a:xfrm>
+          <a:prstGeom prst="rect">
+            <a:avLst/>
+          </a:prstGeom>
+          <a:noFill/>
+          <a:ln/>
+        </p:spPr>
+        <p:txBody>
+          <a:bodyPr wrap="square" rtlCol="0" anchor="ctr"/>
+          <a:lstStyle/>
+          <a:p>
             <a:pPr indent="0" marL="0">
-              <a:buNone/>
-            </a:pPr>
-            <a:r>
-              <a:rPr lang="en-US" sz="1200" dirty="0">
+              <a:lnSpc>
+                <a:spcPts val="400"/>
+              </a:lnSpc>
+              <a:buNone/>
+            </a:pPr>
+            <a:r>
+              <a:rPr lang="en-US" sz="950" dirty="0">
                 <a:solidFill>
                   <a:srgbClr val="1E293B"/>
                 </a:solidFill>
@@ -7800,14 +7857,169 @@
                 <a:ea typeface="Segoe UI" pitchFamily="34" charset="-122"/>
                 <a:cs typeface="Segoe UI" pitchFamily="34" charset="-120"/>
               </a:rPr>
-              <a:t>  All database passwords are salted and hashed using Bcryptjs to shield records from lookup table attacks.
-</a:t>
-            </a:r>
+              <a:t>Columns: id, fullName, username, password, email, mobile, gender, age</a:t>
+            </a:r>
+            <a:endParaRPr lang="en-US" sz="950" dirty="0"/>
+          </a:p>
+        </p:txBody>
+      </p:sp>
+      <p:sp>
+        <p:nvSpPr>
+          <p:cNvPr id="7" name="Shape 5"/>
+          <p:cNvSpPr/>
+          <p:nvPr/>
+        </p:nvSpPr>
+        <p:spPr>
+          <a:xfrm>
+            <a:off x="2697480" y="1371600"/>
+            <a:ext cx="1828800" cy="3017520"/>
+          </a:xfrm>
+          <a:prstGeom prst="rect">
+            <a:avLst/>
+          </a:prstGeom>
+          <a:solidFill>
+            <a:srgbClr val="F8FAFC"/>
+          </a:solidFill>
+          <a:ln w="12700">
+            <a:solidFill>
+              <a:srgbClr val="E2E8F0"/>
+            </a:solidFill>
+            <a:prstDash val="solid"/>
+          </a:ln>
+        </p:spPr>
+      </p:sp>
+      <p:sp>
+        <p:nvSpPr>
+          <p:cNvPr id="8" name="Text 6"/>
+          <p:cNvSpPr/>
+          <p:nvPr/>
+        </p:nvSpPr>
+        <p:spPr>
+          <a:xfrm>
+            <a:off x="2788920" y="1554480"/>
+            <a:ext cx="1645920" cy="274320"/>
+          </a:xfrm>
+          <a:prstGeom prst="rect">
+            <a:avLst/>
+          </a:prstGeom>
+          <a:noFill/>
+          <a:ln/>
+        </p:spPr>
+        <p:txBody>
+          <a:bodyPr wrap="square" rtlCol="0" anchor="ctr"/>
+          <a:lstStyle/>
+          <a:p>
+            <a:pPr algn="ctr" indent="0" marL="0">
+              <a:buNone/>
+            </a:pPr>
+            <a:r>
+              <a:rPr lang="en-US" sz="1300" b="1" dirty="0">
+                <a:solidFill>
+                  <a:srgbClr val="2563EB"/>
+                </a:solidFill>
+                <a:latin typeface="Segoe UI" pitchFamily="34" charset="0"/>
+                <a:ea typeface="Segoe UI" pitchFamily="34" charset="-122"/>
+                <a:cs typeface="Segoe UI" pitchFamily="34" charset="-120"/>
+              </a:rPr>
+              <a:t>doctors</a:t>
+            </a:r>
+            <a:endParaRPr lang="en-US" sz="1300" dirty="0"/>
+          </a:p>
+        </p:txBody>
+      </p:sp>
+      <p:sp>
+        <p:nvSpPr>
+          <p:cNvPr id="9" name="Text 7"/>
+          <p:cNvSpPr/>
+          <p:nvPr/>
+        </p:nvSpPr>
+        <p:spPr>
+          <a:xfrm>
+            <a:off x="2788920" y="1920240"/>
+            <a:ext cx="1645920" cy="2286000"/>
+          </a:xfrm>
+          <a:prstGeom prst="rect">
+            <a:avLst/>
+          </a:prstGeom>
+          <a:noFill/>
+          <a:ln/>
+        </p:spPr>
+        <p:txBody>
+          <a:bodyPr wrap="square" rtlCol="0" anchor="ctr"/>
+          <a:lstStyle/>
+          <a:p>
             <a:pPr indent="0" marL="0">
-              <a:buNone/>
-            </a:pPr>
-            <a:r>
-              <a:rPr lang="en-US" sz="1200" b="1" dirty="0">
+              <a:lnSpc>
+                <a:spcPts val="400"/>
+              </a:lnSpc>
+              <a:buNone/>
+            </a:pPr>
+            <a:r>
+              <a:rPr lang="en-US" sz="950" dirty="0">
+                <a:solidFill>
+                  <a:srgbClr val="1E293B"/>
+                </a:solidFill>
+                <a:latin typeface="Segoe UI" pitchFamily="34" charset="0"/>
+                <a:ea typeface="Segoe UI" pitchFamily="34" charset="-122"/>
+                <a:cs typeface="Segoe UI" pitchFamily="34" charset="-120"/>
+              </a:rPr>
+              <a:t>Columns: id, fullName, username, password, email, specialization, slots (JSON), balance</a:t>
+            </a:r>
+            <a:endParaRPr lang="en-US" sz="950" dirty="0"/>
+          </a:p>
+        </p:txBody>
+      </p:sp>
+      <p:sp>
+        <p:nvSpPr>
+          <p:cNvPr id="10" name="Shape 8"/>
+          <p:cNvSpPr/>
+          <p:nvPr/>
+        </p:nvSpPr>
+        <p:spPr>
+          <a:xfrm>
+            <a:off x="4663440" y="1371600"/>
+            <a:ext cx="1828800" cy="3017520"/>
+          </a:xfrm>
+          <a:prstGeom prst="rect">
+            <a:avLst/>
+          </a:prstGeom>
+          <a:solidFill>
+            <a:srgbClr val="F8FAFC"/>
+          </a:solidFill>
+          <a:ln w="12700">
+            <a:solidFill>
+              <a:srgbClr val="E2E8F0"/>
+            </a:solidFill>
+            <a:prstDash val="solid"/>
+          </a:ln>
+        </p:spPr>
+      </p:sp>
+      <p:sp>
+        <p:nvSpPr>
+          <p:cNvPr id="11" name="Text 9"/>
+          <p:cNvSpPr/>
+          <p:nvPr/>
+        </p:nvSpPr>
+        <p:spPr>
+          <a:xfrm>
+            <a:off x="4754880" y="1554480"/>
+            <a:ext cx="1645920" cy="274320"/>
+          </a:xfrm>
+          <a:prstGeom prst="rect">
+            <a:avLst/>
+          </a:prstGeom>
+          <a:noFill/>
+          <a:ln/>
+        </p:spPr>
+        <p:txBody>
+          <a:bodyPr wrap="square" rtlCol="0" anchor="ctr"/>
+          <a:lstStyle/>
+          <a:p>
+            <a:pPr algn="ctr" indent="0" marL="0">
+              <a:buNone/>
+            </a:pPr>
+            <a:r>
+              <a:rPr lang="en-US" sz="1300" b="1" dirty="0">
                 <a:solidFill>
                   <a:srgbClr val="2563EB"/>
                 </a:solidFill>
@@ -7815,14 +8027,41 @@
                 <a:ea typeface="Segoe UI" pitchFamily="34" charset="-122"/>
                 <a:cs typeface="Segoe UI" pitchFamily="34" charset="-120"/>
               </a:rPr>
-              <a:t>• Dual-Step OTP Flow:
-</a:t>
-            </a:r>
+              <a:t>vendors</a:t>
+            </a:r>
+            <a:endParaRPr lang="en-US" sz="1300" dirty="0"/>
+          </a:p>
+        </p:txBody>
+      </p:sp>
+      <p:sp>
+        <p:nvSpPr>
+          <p:cNvPr id="12" name="Text 10"/>
+          <p:cNvSpPr/>
+          <p:nvPr/>
+        </p:nvSpPr>
+        <p:spPr>
+          <a:xfrm>
+            <a:off x="4754880" y="1920240"/>
+            <a:ext cx="1645920" cy="2286000"/>
+          </a:xfrm>
+          <a:prstGeom prst="rect">
+            <a:avLst/>
+          </a:prstGeom>
+          <a:noFill/>
+          <a:ln/>
+        </p:spPr>
+        <p:txBody>
+          <a:bodyPr wrap="square" rtlCol="0" anchor="ctr"/>
+          <a:lstStyle/>
+          <a:p>
             <a:pPr indent="0" marL="0">
-              <a:buNone/>
-            </a:pPr>
-            <a:r>
-              <a:rPr lang="en-US" sz="1200" dirty="0">
+              <a:lnSpc>
+                <a:spcPts val="400"/>
+              </a:lnSpc>
+              <a:buNone/>
+            </a:pPr>
+            <a:r>
+              <a:rPr lang="en-US" sz="950" dirty="0">
                 <a:solidFill>
                   <a:srgbClr val="1E293B"/>
                 </a:solidFill>
@@ -7830,29 +8069,105 @@
                 <a:ea typeface="Segoe UI" pitchFamily="34" charset="-122"/>
                 <a:cs typeface="Segoe UI" pitchFamily="34" charset="-120"/>
               </a:rPr>
-              <a:t>  Patient login triggers an in-memory verification key sent to email (with a master 123456 bypass code for testing).
-</a:t>
-            </a:r>
+              <a:t>Columns: id, fullName, username, storeName, inventory (JSON), balance</a:t>
+            </a:r>
+            <a:endParaRPr lang="en-US" sz="950" dirty="0"/>
+          </a:p>
+        </p:txBody>
+      </p:sp>
+      <p:sp>
+        <p:nvSpPr>
+          <p:cNvPr id="13" name="Shape 11"/>
+          <p:cNvSpPr/>
+          <p:nvPr/>
+        </p:nvSpPr>
+        <p:spPr>
+          <a:xfrm>
+            <a:off x="6629400" y="1371600"/>
+            <a:ext cx="1828800" cy="3017520"/>
+          </a:xfrm>
+          <a:prstGeom prst="rect">
+            <a:avLst/>
+          </a:prstGeom>
+          <a:solidFill>
+            <a:srgbClr val="F8FAFC"/>
+          </a:solidFill>
+          <a:ln w="12700">
+            <a:solidFill>
+              <a:srgbClr val="E2E8F0"/>
+            </a:solidFill>
+            <a:prstDash val="solid"/>
+          </a:ln>
+        </p:spPr>
+      </p:sp>
+      <p:sp>
+        <p:nvSpPr>
+          <p:cNvPr id="14" name="Text 12"/>
+          <p:cNvSpPr/>
+          <p:nvPr/>
+        </p:nvSpPr>
+        <p:spPr>
+          <a:xfrm>
+            <a:off x="6720840" y="1554480"/>
+            <a:ext cx="1645920" cy="274320"/>
+          </a:xfrm>
+          <a:prstGeom prst="rect">
+            <a:avLst/>
+          </a:prstGeom>
+          <a:noFill/>
+          <a:ln/>
+        </p:spPr>
+        <p:txBody>
+          <a:bodyPr wrap="square" rtlCol="0" anchor="ctr"/>
+          <a:lstStyle/>
+          <a:p>
+            <a:pPr algn="ctr" indent="0" marL="0">
+              <a:buNone/>
+            </a:pPr>
+            <a:r>
+              <a:rPr lang="en-US" sz="1300" b="1" dirty="0">
+                <a:solidFill>
+                  <a:srgbClr val="2563EB"/>
+                </a:solidFill>
+                <a:latin typeface="Segoe UI" pitchFamily="34" charset="0"/>
+                <a:ea typeface="Segoe UI" pitchFamily="34" charset="-122"/>
+                <a:cs typeface="Segoe UI" pitchFamily="34" charset="-120"/>
+              </a:rPr>
+              <a:t>appointments</a:t>
+            </a:r>
+            <a:endParaRPr lang="en-US" sz="1300" dirty="0"/>
+          </a:p>
+        </p:txBody>
+      </p:sp>
+      <p:sp>
+        <p:nvSpPr>
+          <p:cNvPr id="15" name="Text 13"/>
+          <p:cNvSpPr/>
+          <p:nvPr/>
+        </p:nvSpPr>
+        <p:spPr>
+          <a:xfrm>
+            <a:off x="6720840" y="1920240"/>
+            <a:ext cx="1645920" cy="2286000"/>
+          </a:xfrm>
+          <a:prstGeom prst="rect">
+            <a:avLst/>
+          </a:prstGeom>
+          <a:noFill/>
+          <a:ln/>
+        </p:spPr>
+        <p:txBody>
+          <a:bodyPr wrap="square" rtlCol="0" anchor="ctr"/>
+          <a:lstStyle/>
+          <a:p>
             <a:pPr indent="0" marL="0">
-              <a:buNone/>
-            </a:pPr>
-            <a:r>
-              <a:rPr lang="en-US" sz="1200" b="1" dirty="0">
-                <a:solidFill>
-                  <a:srgbClr val="2563EB"/>
-                </a:solidFill>
-                <a:latin typeface="Segoe UI" pitchFamily="34" charset="0"/>
-                <a:ea typeface="Segoe UI" pitchFamily="34" charset="-122"/>
-                <a:cs typeface="Segoe UI" pitchFamily="34" charset="-120"/>
-              </a:rPr>
-              <a:t>• Secure JWT Claims:
-</a:t>
-            </a:r>
-            <a:pPr indent="0" marL="0">
-              <a:buNone/>
-            </a:pPr>
-            <a:r>
-              <a:rPr lang="en-US" sz="1200" dirty="0">
+              <a:lnSpc>
+                <a:spcPts val="400"/>
+              </a:lnSpc>
+              <a:buNone/>
+            </a:pPr>
+            <a:r>
+              <a:rPr lang="en-US" sz="950" dirty="0">
                 <a:solidFill>
                   <a:srgbClr val="1E293B"/>
                 </a:solidFill>
@@ -7860,9 +8175,9 @@
                 <a:ea typeface="Segoe UI" pitchFamily="34" charset="-122"/>
                 <a:cs typeface="Segoe UI" pitchFamily="34" charset="-120"/>
               </a:rPr>
-              <a:t>  Stateless JSON Web Tokens store userId and userRole configurations, validated at the API route boundary.</a:t>
-            </a:r>
-            <a:endParaRPr lang="en-US" sz="1200" dirty="0"/>
+              <a:t>Columns: id, patientUsername, doctorUsername, specialization, slot, symptoms, paymentStatus, escrowStatus</a:t>
+            </a:r>
+            <a:endParaRPr lang="en-US" sz="950" dirty="0"/>
           </a:p>
         </p:txBody>
       </p:sp>
@@ -7916,7 +8231,7 @@
               <a:buNone/>
             </a:pPr>
             <a:r>
-              <a:rPr lang="en-US" sz="2800" b="1" dirty="0">
+              <a:rPr lang="en-US" sz="2600" b="1" dirty="0">
                 <a:solidFill>
                   <a:srgbClr val="2563EB"/>
                 </a:solidFill>
@@ -7924,22 +8239,42 @@
                 <a:ea typeface="Segoe UI" pitchFamily="34" charset="-122"/>
                 <a:cs typeface="Segoe UI" pitchFamily="34" charset="-120"/>
               </a:rPr>
-              <a:t>Relational Database Schema</a:t>
-            </a:r>
-            <a:endParaRPr lang="en-US" sz="2800" dirty="0"/>
-          </a:p>
-        </p:txBody>
-      </p:sp>
-      <p:sp>
-        <p:nvSpPr>
-          <p:cNvPr id="3" name="Text 1"/>
-          <p:cNvSpPr/>
-          <p:nvPr/>
-        </p:nvSpPr>
-        <p:spPr>
-          <a:xfrm>
-            <a:off x="731520" y="1005840"/>
-            <a:ext cx="7772400" cy="365760"/>
+              <a:t>Low-Level Directory Layout</a:t>
+            </a:r>
+            <a:endParaRPr lang="en-US" sz="2600" dirty="0"/>
+          </a:p>
+        </p:txBody>
+      </p:sp>
+      <p:sp>
+        <p:nvSpPr>
+          <p:cNvPr id="3" name="Shape 1"/>
+          <p:cNvSpPr/>
+          <p:nvPr/>
+        </p:nvSpPr>
+        <p:spPr>
+          <a:xfrm>
+            <a:off x="731520" y="1188720"/>
+            <a:ext cx="1828800" cy="640080"/>
+          </a:xfrm>
+          <a:prstGeom prst="rect">
+            <a:avLst/>
+          </a:prstGeom>
+          <a:solidFill>
+            <a:srgbClr val="2563EB"/>
+          </a:solidFill>
+          <a:ln/>
+        </p:spPr>
+      </p:sp>
+      <p:sp>
+        <p:nvSpPr>
+          <p:cNvPr id="4" name="Text 2"/>
+          <p:cNvSpPr/>
+          <p:nvPr/>
+        </p:nvSpPr>
+        <p:spPr>
+          <a:xfrm>
+            <a:off x="731520" y="1325880"/>
+            <a:ext cx="1828800" cy="365760"/>
           </a:xfrm>
           <a:prstGeom prst="rect">
             <a:avLst/>
@@ -7951,34 +8286,34 @@
           <a:bodyPr wrap="square" rtlCol="0" anchor="ctr"/>
           <a:lstStyle/>
           <a:p>
-            <a:pPr indent="0" marL="0">
-              <a:buNone/>
-            </a:pPr>
-            <a:r>
-              <a:rPr lang="en-US" sz="1300" dirty="0">
-                <a:solidFill>
-                  <a:srgbClr val="64748B"/>
-                </a:solidFill>
-                <a:latin typeface="Segoe UI" pitchFamily="34" charset="0"/>
-                <a:ea typeface="Segoe UI" pitchFamily="34" charset="-122"/>
-                <a:cs typeface="Segoe UI" pitchFamily="34" charset="-120"/>
-              </a:rPr>
-              <a:t>Seven highly structured tables establishing clean reference integrity across domains:</a:t>
-            </a:r>
-            <a:endParaRPr lang="en-US" sz="1300" dirty="0"/>
-          </a:p>
-        </p:txBody>
-      </p:sp>
-      <p:sp>
-        <p:nvSpPr>
-          <p:cNvPr id="4" name="Shape 2"/>
-          <p:cNvSpPr/>
-          <p:nvPr/>
-        </p:nvSpPr>
-        <p:spPr>
-          <a:xfrm>
-            <a:off x="731520" y="1463040"/>
-            <a:ext cx="1828800" cy="2926080"/>
+            <a:pPr algn="ctr" indent="0" marL="0">
+              <a:buNone/>
+            </a:pPr>
+            <a:r>
+              <a:rPr lang="en-US" sz="1100" b="1" dirty="0">
+                <a:solidFill>
+                  <a:srgbClr val="FFFFFF"/>
+                </a:solidFill>
+                <a:latin typeface="Segoe UI" pitchFamily="34" charset="0"/>
+                <a:ea typeface="Segoe UI" pitchFamily="34" charset="-122"/>
+                <a:cs typeface="Segoe UI" pitchFamily="34" charset="-120"/>
+              </a:rPr>
+              <a:t>Routes Module</a:t>
+            </a:r>
+            <a:endParaRPr lang="en-US" sz="1100" dirty="0"/>
+          </a:p>
+        </p:txBody>
+      </p:sp>
+      <p:sp>
+        <p:nvSpPr>
+          <p:cNvPr id="5" name="Shape 3"/>
+          <p:cNvSpPr/>
+          <p:nvPr/>
+        </p:nvSpPr>
+        <p:spPr>
+          <a:xfrm>
+            <a:off x="2651760" y="1188720"/>
+            <a:ext cx="5760720" cy="640080"/>
           </a:xfrm>
           <a:prstGeom prst="rect">
             <a:avLst/>
@@ -7996,14 +8331,14 @@
       </p:sp>
       <p:sp>
         <p:nvSpPr>
-          <p:cNvPr id="5" name="Text 3"/>
-          <p:cNvSpPr/>
-          <p:nvPr/>
-        </p:nvSpPr>
-        <p:spPr>
-          <a:xfrm>
-            <a:off x="822960" y="1645920"/>
-            <a:ext cx="1645920" cy="274320"/>
+          <p:cNvPr id="6" name="Text 4"/>
+          <p:cNvSpPr/>
+          <p:nvPr/>
+        </p:nvSpPr>
+        <p:spPr>
+          <a:xfrm>
+            <a:off x="2834640" y="1280160"/>
+            <a:ext cx="5486400" cy="457200"/>
           </a:xfrm>
           <a:prstGeom prst="rect">
             <a:avLst/>
@@ -8015,73 +8350,93 @@
           <a:bodyPr wrap="square" rtlCol="0" anchor="ctr"/>
           <a:lstStyle/>
           <a:p>
+            <a:pPr indent="0" marL="0">
+              <a:buNone/>
+            </a:pPr>
+            <a:r>
+              <a:rPr lang="en-US" sz="950" dirty="0">
+                <a:solidFill>
+                  <a:srgbClr val="1E293B"/>
+                </a:solidFill>
+                <a:latin typeface="Segoe UI" pitchFamily="34" charset="0"/>
+                <a:ea typeface="Segoe UI" pitchFamily="34" charset="-122"/>
+                <a:cs typeface="Segoe UI" pitchFamily="34" charset="-120"/>
+              </a:rPr>
+              <a:t>publicRoutes.js, appointmentRoutes.js   |   Sets API endpoints and connects route paths to controllers while managing authorization.</a:t>
+            </a:r>
+            <a:endParaRPr lang="en-US" sz="950" dirty="0"/>
+          </a:p>
+        </p:txBody>
+      </p:sp>
+      <p:sp>
+        <p:nvSpPr>
+          <p:cNvPr id="7" name="Shape 5"/>
+          <p:cNvSpPr/>
+          <p:nvPr/>
+        </p:nvSpPr>
+        <p:spPr>
+          <a:xfrm>
+            <a:off x="731520" y="1965960"/>
+            <a:ext cx="1828800" cy="640080"/>
+          </a:xfrm>
+          <a:prstGeom prst="rect">
+            <a:avLst/>
+          </a:prstGeom>
+          <a:solidFill>
+            <a:srgbClr val="2563EB"/>
+          </a:solidFill>
+          <a:ln/>
+        </p:spPr>
+      </p:sp>
+      <p:sp>
+        <p:nvSpPr>
+          <p:cNvPr id="8" name="Text 6"/>
+          <p:cNvSpPr/>
+          <p:nvPr/>
+        </p:nvSpPr>
+        <p:spPr>
+          <a:xfrm>
+            <a:off x="731520" y="2103120"/>
+            <a:ext cx="1828800" cy="365760"/>
+          </a:xfrm>
+          <a:prstGeom prst="rect">
+            <a:avLst/>
+          </a:prstGeom>
+          <a:noFill/>
+          <a:ln/>
+        </p:spPr>
+        <p:txBody>
+          <a:bodyPr wrap="square" rtlCol="0" anchor="ctr"/>
+          <a:lstStyle/>
+          <a:p>
             <a:pPr algn="ctr" indent="0" marL="0">
               <a:buNone/>
             </a:pPr>
             <a:r>
-              <a:rPr lang="en-US" sz="1400" b="1" dirty="0">
-                <a:solidFill>
-                  <a:srgbClr val="2563EB"/>
-                </a:solidFill>
-                <a:latin typeface="Segoe UI" pitchFamily="34" charset="0"/>
-                <a:ea typeface="Segoe UI" pitchFamily="34" charset="-122"/>
-                <a:cs typeface="Segoe UI" pitchFamily="34" charset="-120"/>
-              </a:rPr>
-              <a:t>users</a:t>
-            </a:r>
-            <a:endParaRPr lang="en-US" sz="1400" dirty="0"/>
-          </a:p>
-        </p:txBody>
-      </p:sp>
-      <p:sp>
-        <p:nvSpPr>
-          <p:cNvPr id="6" name="Text 4"/>
-          <p:cNvSpPr/>
-          <p:nvPr/>
-        </p:nvSpPr>
-        <p:spPr>
-          <a:xfrm>
-            <a:off x="822960" y="2011680"/>
-            <a:ext cx="1645920" cy="2194560"/>
-          </a:xfrm>
-          <a:prstGeom prst="rect">
-            <a:avLst/>
-          </a:prstGeom>
-          <a:noFill/>
-          <a:ln/>
-        </p:spPr>
-        <p:txBody>
-          <a:bodyPr wrap="square" rtlCol="0" anchor="ctr"/>
-          <a:lstStyle/>
-          <a:p>
-            <a:pPr indent="0" marL="0">
-              <a:buNone/>
-            </a:pPr>
-            <a:r>
-              <a:rPr lang="en-US" sz="900" dirty="0">
-                <a:solidFill>
-                  <a:srgbClr val="1E293B"/>
-                </a:solidFill>
-                <a:latin typeface="Segoe UI" pitchFamily="34" charset="0"/>
-                <a:ea typeface="Segoe UI" pitchFamily="34" charset="-122"/>
-                <a:cs typeface="Segoe UI" pitchFamily="34" charset="-120"/>
-              </a:rPr>
-              <a:t>Fields: id, fullName, username, password, email, mobile, gender, age</a:t>
-            </a:r>
-            <a:endParaRPr lang="en-US" sz="900" dirty="0"/>
-          </a:p>
-        </p:txBody>
-      </p:sp>
-      <p:sp>
-        <p:nvSpPr>
-          <p:cNvPr id="7" name="Shape 5"/>
-          <p:cNvSpPr/>
-          <p:nvPr/>
-        </p:nvSpPr>
-        <p:spPr>
-          <a:xfrm>
-            <a:off x="2697480" y="1463040"/>
-            <a:ext cx="1828800" cy="2926080"/>
+              <a:rPr lang="en-US" sz="1100" b="1" dirty="0">
+                <a:solidFill>
+                  <a:srgbClr val="FFFFFF"/>
+                </a:solidFill>
+                <a:latin typeface="Segoe UI" pitchFamily="34" charset="0"/>
+                <a:ea typeface="Segoe UI" pitchFamily="34" charset="-122"/>
+                <a:cs typeface="Segoe UI" pitchFamily="34" charset="-120"/>
+              </a:rPr>
+              <a:t>Controllers</a:t>
+            </a:r>
+            <a:endParaRPr lang="en-US" sz="1100" dirty="0"/>
+          </a:p>
+        </p:txBody>
+      </p:sp>
+      <p:sp>
+        <p:nvSpPr>
+          <p:cNvPr id="9" name="Shape 7"/>
+          <p:cNvSpPr/>
+          <p:nvPr/>
+        </p:nvSpPr>
+        <p:spPr>
+          <a:xfrm>
+            <a:off x="2651760" y="1965960"/>
+            <a:ext cx="5760720" cy="640080"/>
           </a:xfrm>
           <a:prstGeom prst="rect">
             <a:avLst/>
@@ -8099,14 +8454,14 @@
       </p:sp>
       <p:sp>
         <p:nvSpPr>
-          <p:cNvPr id="8" name="Text 6"/>
-          <p:cNvSpPr/>
-          <p:nvPr/>
-        </p:nvSpPr>
-        <p:spPr>
-          <a:xfrm>
-            <a:off x="2788920" y="1645920"/>
-            <a:ext cx="1645920" cy="274320"/>
+          <p:cNvPr id="10" name="Text 8"/>
+          <p:cNvSpPr/>
+          <p:nvPr/>
+        </p:nvSpPr>
+        <p:spPr>
+          <a:xfrm>
+            <a:off x="2834640" y="2057400"/>
+            <a:ext cx="5486400" cy="457200"/>
           </a:xfrm>
           <a:prstGeom prst="rect">
             <a:avLst/>
@@ -8118,73 +8473,93 @@
           <a:bodyPr wrap="square" rtlCol="0" anchor="ctr"/>
           <a:lstStyle/>
           <a:p>
+            <a:pPr indent="0" marL="0">
+              <a:buNone/>
+            </a:pPr>
+            <a:r>
+              <a:rPr lang="en-US" sz="950" dirty="0">
+                <a:solidFill>
+                  <a:srgbClr val="1E293B"/>
+                </a:solidFill>
+                <a:latin typeface="Segoe UI" pitchFamily="34" charset="0"/>
+                <a:ea typeface="Segoe UI" pitchFamily="34" charset="-122"/>
+                <a:cs typeface="Segoe UI" pitchFamily="34" charset="-120"/>
+              </a:rPr>
+              <a:t>authController.js, appointmentController.js   |   Verifies user request parameters and formats success/error JSON payloads.</a:t>
+            </a:r>
+            <a:endParaRPr lang="en-US" sz="950" dirty="0"/>
+          </a:p>
+        </p:txBody>
+      </p:sp>
+      <p:sp>
+        <p:nvSpPr>
+          <p:cNvPr id="11" name="Shape 9"/>
+          <p:cNvSpPr/>
+          <p:nvPr/>
+        </p:nvSpPr>
+        <p:spPr>
+          <a:xfrm>
+            <a:off x="731520" y="2743200"/>
+            <a:ext cx="1828800" cy="640080"/>
+          </a:xfrm>
+          <a:prstGeom prst="rect">
+            <a:avLst/>
+          </a:prstGeom>
+          <a:solidFill>
+            <a:srgbClr val="2563EB"/>
+          </a:solidFill>
+          <a:ln/>
+        </p:spPr>
+      </p:sp>
+      <p:sp>
+        <p:nvSpPr>
+          <p:cNvPr id="12" name="Text 10"/>
+          <p:cNvSpPr/>
+          <p:nvPr/>
+        </p:nvSpPr>
+        <p:spPr>
+          <a:xfrm>
+            <a:off x="731520" y="2880360"/>
+            <a:ext cx="1828800" cy="365760"/>
+          </a:xfrm>
+          <a:prstGeom prst="rect">
+            <a:avLst/>
+          </a:prstGeom>
+          <a:noFill/>
+          <a:ln/>
+        </p:spPr>
+        <p:txBody>
+          <a:bodyPr wrap="square" rtlCol="0" anchor="ctr"/>
+          <a:lstStyle/>
+          <a:p>
             <a:pPr algn="ctr" indent="0" marL="0">
               <a:buNone/>
             </a:pPr>
             <a:r>
-              <a:rPr lang="en-US" sz="1400" b="1" dirty="0">
-                <a:solidFill>
-                  <a:srgbClr val="2563EB"/>
-                </a:solidFill>
-                <a:latin typeface="Segoe UI" pitchFamily="34" charset="0"/>
-                <a:ea typeface="Segoe UI" pitchFamily="34" charset="-122"/>
-                <a:cs typeface="Segoe UI" pitchFamily="34" charset="-120"/>
-              </a:rPr>
-              <a:t>doctors</a:t>
-            </a:r>
-            <a:endParaRPr lang="en-US" sz="1400" dirty="0"/>
-          </a:p>
-        </p:txBody>
-      </p:sp>
-      <p:sp>
-        <p:nvSpPr>
-          <p:cNvPr id="9" name="Text 7"/>
-          <p:cNvSpPr/>
-          <p:nvPr/>
-        </p:nvSpPr>
-        <p:spPr>
-          <a:xfrm>
-            <a:off x="2788920" y="2011680"/>
-            <a:ext cx="1645920" cy="2194560"/>
-          </a:xfrm>
-          <a:prstGeom prst="rect">
-            <a:avLst/>
-          </a:prstGeom>
-          <a:noFill/>
-          <a:ln/>
-        </p:spPr>
-        <p:txBody>
-          <a:bodyPr wrap="square" rtlCol="0" anchor="ctr"/>
-          <a:lstStyle/>
-          <a:p>
-            <a:pPr indent="0" marL="0">
-              <a:buNone/>
-            </a:pPr>
-            <a:r>
-              <a:rPr lang="en-US" sz="900" dirty="0">
-                <a:solidFill>
-                  <a:srgbClr val="1E293B"/>
-                </a:solidFill>
-                <a:latin typeface="Segoe UI" pitchFamily="34" charset="0"/>
-                <a:ea typeface="Segoe UI" pitchFamily="34" charset="-122"/>
-                <a:cs typeface="Segoe UI" pitchFamily="34" charset="-120"/>
-              </a:rPr>
-              <a:t>Fields: id, fullName, username, password, email, specialization, slots (JSON), balance</a:t>
-            </a:r>
-            <a:endParaRPr lang="en-US" sz="900" dirty="0"/>
-          </a:p>
-        </p:txBody>
-      </p:sp>
-      <p:sp>
-        <p:nvSpPr>
-          <p:cNvPr id="10" name="Shape 8"/>
-          <p:cNvSpPr/>
-          <p:nvPr/>
-        </p:nvSpPr>
-        <p:spPr>
-          <a:xfrm>
-            <a:off x="4663440" y="1463040"/>
-            <a:ext cx="1828800" cy="2926080"/>
+              <a:rPr lang="en-US" sz="1100" b="1" dirty="0">
+                <a:solidFill>
+                  <a:srgbClr val="FFFFFF"/>
+                </a:solidFill>
+                <a:latin typeface="Segoe UI" pitchFamily="34" charset="0"/>
+                <a:ea typeface="Segoe UI" pitchFamily="34" charset="-122"/>
+                <a:cs typeface="Segoe UI" pitchFamily="34" charset="-120"/>
+              </a:rPr>
+              <a:t>Services</a:t>
+            </a:r>
+            <a:endParaRPr lang="en-US" sz="1100" dirty="0"/>
+          </a:p>
+        </p:txBody>
+      </p:sp>
+      <p:sp>
+        <p:nvSpPr>
+          <p:cNvPr id="13" name="Shape 11"/>
+          <p:cNvSpPr/>
+          <p:nvPr/>
+        </p:nvSpPr>
+        <p:spPr>
+          <a:xfrm>
+            <a:off x="2651760" y="2743200"/>
+            <a:ext cx="5760720" cy="640080"/>
           </a:xfrm>
           <a:prstGeom prst="rect">
             <a:avLst/>
@@ -8202,14 +8577,14 @@
       </p:sp>
       <p:sp>
         <p:nvSpPr>
-          <p:cNvPr id="11" name="Text 9"/>
-          <p:cNvSpPr/>
-          <p:nvPr/>
-        </p:nvSpPr>
-        <p:spPr>
-          <a:xfrm>
-            <a:off x="4754880" y="1645920"/>
-            <a:ext cx="1645920" cy="274320"/>
+          <p:cNvPr id="14" name="Text 12"/>
+          <p:cNvSpPr/>
+          <p:nvPr/>
+        </p:nvSpPr>
+        <p:spPr>
+          <a:xfrm>
+            <a:off x="2834640" y="2834640"/>
+            <a:ext cx="5486400" cy="457200"/>
           </a:xfrm>
           <a:prstGeom prst="rect">
             <a:avLst/>
@@ -8221,73 +8596,93 @@
           <a:bodyPr wrap="square" rtlCol="0" anchor="ctr"/>
           <a:lstStyle/>
           <a:p>
+            <a:pPr indent="0" marL="0">
+              <a:buNone/>
+            </a:pPr>
+            <a:r>
+              <a:rPr lang="en-US" sz="950" dirty="0">
+                <a:solidFill>
+                  <a:srgbClr val="1E293B"/>
+                </a:solidFill>
+                <a:latin typeface="Segoe UI" pitchFamily="34" charset="0"/>
+                <a:ea typeface="Segoe UI" pitchFamily="34" charset="-122"/>
+                <a:cs typeface="Segoe UI" pitchFamily="34" charset="-120"/>
+              </a:rPr>
+              <a:t>userService.js, otpService.js, emailService.js   |   Performs system business validation, hashes keys, and manages OTP sessions.</a:t>
+            </a:r>
+            <a:endParaRPr lang="en-US" sz="950" dirty="0"/>
+          </a:p>
+        </p:txBody>
+      </p:sp>
+      <p:sp>
+        <p:nvSpPr>
+          <p:cNvPr id="15" name="Shape 13"/>
+          <p:cNvSpPr/>
+          <p:nvPr/>
+        </p:nvSpPr>
+        <p:spPr>
+          <a:xfrm>
+            <a:off x="731520" y="3520440"/>
+            <a:ext cx="1828800" cy="640080"/>
+          </a:xfrm>
+          <a:prstGeom prst="rect">
+            <a:avLst/>
+          </a:prstGeom>
+          <a:solidFill>
+            <a:srgbClr val="2563EB"/>
+          </a:solidFill>
+          <a:ln/>
+        </p:spPr>
+      </p:sp>
+      <p:sp>
+        <p:nvSpPr>
+          <p:cNvPr id="16" name="Text 14"/>
+          <p:cNvSpPr/>
+          <p:nvPr/>
+        </p:nvSpPr>
+        <p:spPr>
+          <a:xfrm>
+            <a:off x="731520" y="3657600"/>
+            <a:ext cx="1828800" cy="365760"/>
+          </a:xfrm>
+          <a:prstGeom prst="rect">
+            <a:avLst/>
+          </a:prstGeom>
+          <a:noFill/>
+          <a:ln/>
+        </p:spPr>
+        <p:txBody>
+          <a:bodyPr wrap="square" rtlCol="0" anchor="ctr"/>
+          <a:lstStyle/>
+          <a:p>
             <a:pPr algn="ctr" indent="0" marL="0">
               <a:buNone/>
             </a:pPr>
             <a:r>
-              <a:rPr lang="en-US" sz="1400" b="1" dirty="0">
-                <a:solidFill>
-                  <a:srgbClr val="2563EB"/>
-                </a:solidFill>
-                <a:latin typeface="Segoe UI" pitchFamily="34" charset="0"/>
-                <a:ea typeface="Segoe UI" pitchFamily="34" charset="-122"/>
-                <a:cs typeface="Segoe UI" pitchFamily="34" charset="-120"/>
-              </a:rPr>
-              <a:t>vendors</a:t>
-            </a:r>
-            <a:endParaRPr lang="en-US" sz="1400" dirty="0"/>
-          </a:p>
-        </p:txBody>
-      </p:sp>
-      <p:sp>
-        <p:nvSpPr>
-          <p:cNvPr id="12" name="Text 10"/>
-          <p:cNvSpPr/>
-          <p:nvPr/>
-        </p:nvSpPr>
-        <p:spPr>
-          <a:xfrm>
-            <a:off x="4754880" y="2011680"/>
-            <a:ext cx="1645920" cy="2194560"/>
-          </a:xfrm>
-          <a:prstGeom prst="rect">
-            <a:avLst/>
-          </a:prstGeom>
-          <a:noFill/>
-          <a:ln/>
-        </p:spPr>
-        <p:txBody>
-          <a:bodyPr wrap="square" rtlCol="0" anchor="ctr"/>
-          <a:lstStyle/>
-          <a:p>
-            <a:pPr indent="0" marL="0">
-              <a:buNone/>
-            </a:pPr>
-            <a:r>
-              <a:rPr lang="en-US" sz="900" dirty="0">
-                <a:solidFill>
-                  <a:srgbClr val="1E293B"/>
-                </a:solidFill>
-                <a:latin typeface="Segoe UI" pitchFamily="34" charset="0"/>
-                <a:ea typeface="Segoe UI" pitchFamily="34" charset="-122"/>
-                <a:cs typeface="Segoe UI" pitchFamily="34" charset="-120"/>
-              </a:rPr>
-              <a:t>Fields: id, fullName, username, storeName, inventory (JSON), balance</a:t>
-            </a:r>
-            <a:endParaRPr lang="en-US" sz="900" dirty="0"/>
-          </a:p>
-        </p:txBody>
-      </p:sp>
-      <p:sp>
-        <p:nvSpPr>
-          <p:cNvPr id="13" name="Shape 11"/>
-          <p:cNvSpPr/>
-          <p:nvPr/>
-        </p:nvSpPr>
-        <p:spPr>
-          <a:xfrm>
-            <a:off x="6629400" y="1463040"/>
-            <a:ext cx="1828800" cy="2926080"/>
+              <a:rPr lang="en-US" sz="1100" b="1" dirty="0">
+                <a:solidFill>
+                  <a:srgbClr val="FFFFFF"/>
+                </a:solidFill>
+                <a:latin typeface="Segoe UI" pitchFamily="34" charset="0"/>
+                <a:ea typeface="Segoe UI" pitchFamily="34" charset="-122"/>
+                <a:cs typeface="Segoe UI" pitchFamily="34" charset="-120"/>
+              </a:rPr>
+              <a:t>Repositories</a:t>
+            </a:r>
+            <a:endParaRPr lang="en-US" sz="1100" dirty="0"/>
+          </a:p>
+        </p:txBody>
+      </p:sp>
+      <p:sp>
+        <p:nvSpPr>
+          <p:cNvPr id="17" name="Shape 15"/>
+          <p:cNvSpPr/>
+          <p:nvPr/>
+        </p:nvSpPr>
+        <p:spPr>
+          <a:xfrm>
+            <a:off x="2651760" y="3520440"/>
+            <a:ext cx="5760720" cy="640080"/>
           </a:xfrm>
           <a:prstGeom prst="rect">
             <a:avLst/>
@@ -8305,14 +8700,14 @@
       </p:sp>
       <p:sp>
         <p:nvSpPr>
-          <p:cNvPr id="14" name="Text 12"/>
-          <p:cNvSpPr/>
-          <p:nvPr/>
-        </p:nvSpPr>
-        <p:spPr>
-          <a:xfrm>
-            <a:off x="6720840" y="1645920"/>
-            <a:ext cx="1645920" cy="274320"/>
+          <p:cNvPr id="18" name="Text 16"/>
+          <p:cNvSpPr/>
+          <p:nvPr/>
+        </p:nvSpPr>
+        <p:spPr>
+          <a:xfrm>
+            <a:off x="2834640" y="3611880"/>
+            <a:ext cx="5486400" cy="457200"/>
           </a:xfrm>
           <a:prstGeom prst="rect">
             <a:avLst/>
@@ -8324,50 +8719,11 @@
           <a:bodyPr wrap="square" rtlCol="0" anchor="ctr"/>
           <a:lstStyle/>
           <a:p>
-            <a:pPr algn="ctr" indent="0" marL="0">
-              <a:buNone/>
-            </a:pPr>
-            <a:r>
-              <a:rPr lang="en-US" sz="1400" b="1" dirty="0">
-                <a:solidFill>
-                  <a:srgbClr val="2563EB"/>
-                </a:solidFill>
-                <a:latin typeface="Segoe UI" pitchFamily="34" charset="0"/>
-                <a:ea typeface="Segoe UI" pitchFamily="34" charset="-122"/>
-                <a:cs typeface="Segoe UI" pitchFamily="34" charset="-120"/>
-              </a:rPr>
-              <a:t>appointments</a:t>
-            </a:r>
-            <a:endParaRPr lang="en-US" sz="1400" dirty="0"/>
-          </a:p>
-        </p:txBody>
-      </p:sp>
-      <p:sp>
-        <p:nvSpPr>
-          <p:cNvPr id="15" name="Text 13"/>
-          <p:cNvSpPr/>
-          <p:nvPr/>
-        </p:nvSpPr>
-        <p:spPr>
-          <a:xfrm>
-            <a:off x="6720840" y="2011680"/>
-            <a:ext cx="1645920" cy="2194560"/>
-          </a:xfrm>
-          <a:prstGeom prst="rect">
-            <a:avLst/>
-          </a:prstGeom>
-          <a:noFill/>
-          <a:ln/>
-        </p:spPr>
-        <p:txBody>
-          <a:bodyPr wrap="square" rtlCol="0" anchor="ctr"/>
-          <a:lstStyle/>
-          <a:p>
             <a:pPr indent="0" marL="0">
               <a:buNone/>
             </a:pPr>
             <a:r>
-              <a:rPr lang="en-US" sz="900" dirty="0">
+              <a:rPr lang="en-US" sz="950" dirty="0">
                 <a:solidFill>
                   <a:srgbClr val="1E293B"/>
                 </a:solidFill>
@@ -8375,9 +8731,9 @@
                 <a:ea typeface="Segoe UI" pitchFamily="34" charset="-122"/>
                 <a:cs typeface="Segoe UI" pitchFamily="34" charset="-120"/>
               </a:rPr>
-              <a:t>Fields: id, patientUsername, doctorUsername, specialization, slot, symptoms, paymentStatus, escrowStatus</a:t>
-            </a:r>
-            <a:endParaRPr lang="en-US" sz="900" dirty="0"/>
+              <a:t>doctorRepository.js, appointmentRepository.js   |   Writes clean SQL transactions. Keeps database logic isolated for easy testing.</a:t>
+            </a:r>
+            <a:endParaRPr lang="en-US" sz="950" dirty="0"/>
           </a:p>
         </p:txBody>
       </p:sp>

</xml_diff>